<commit_message>
Additional sources and why Opus for the Synthesis
</commit_message>
<xml_diff>
--- a/The KnowledgeHub/Knowledge-Hub-2026-06-19.pptx
+++ b/The KnowledgeHub/Knowledge-Hub-2026-06-19.pptx
@@ -5,7 +5,7 @@
     <p:sldMasterId id="2147483648" r:id="rId1"/>
   </p:sldMasterIdLst>
   <p:notesMasterIdLst>
-    <p:notesMasterId r:id="rId28"/>
+    <p:notesMasterId r:id="rId29"/>
   </p:notesMasterIdLst>
   <p:sldIdLst>
     <p:sldId id="256" r:id="rId2"/>
@@ -30,10 +30,11 @@
     <p:sldId id="272" r:id="rId21"/>
     <p:sldId id="273" r:id="rId22"/>
     <p:sldId id="274" r:id="rId23"/>
-    <p:sldId id="275" r:id="rId24"/>
-    <p:sldId id="277" r:id="rId25"/>
-    <p:sldId id="278" r:id="rId26"/>
-    <p:sldId id="279" r:id="rId27"/>
+    <p:sldId id="282" r:id="rId24"/>
+    <p:sldId id="275" r:id="rId25"/>
+    <p:sldId id="277" r:id="rId26"/>
+    <p:sldId id="278" r:id="rId27"/>
+    <p:sldId id="279" r:id="rId28"/>
   </p:sldIdLst>
   <p:sldSz cx="9144000" cy="5143500" type="screen16x9"/>
   <p:notesSz cx="5143500" cy="9144000"/>
@@ -1671,7 +1672,7 @@
           <a:p>
             <a:fld id="{F7021451-1387-4CA6-816F-3879F97B5CBC}" type="slidenum">
               <a:rPr lang="en-US"/>
-              <a:t>23</a:t>
+              <a:t>24</a:t>
             </a:fld>
             <a:endParaRPr lang="en-US"/>
           </a:p>
@@ -13860,6 +13861,744 @@
 
 <file path=ppt/slides/slide23.xml><?xml version="1.0" encoding="utf-8"?>
 <p:sld xmlns:a="http://schemas.openxmlformats.org/drawingml/2006/main" xmlns:r="http://schemas.openxmlformats.org/officeDocument/2006/relationships" xmlns:p="http://schemas.openxmlformats.org/presentationml/2006/main">
+  <p:cSld>
+    <p:spTree>
+      <p:nvGrpSpPr>
+        <p:cNvPr id="1" name=""/>
+        <p:cNvGrpSpPr/>
+        <p:nvPr/>
+      </p:nvGrpSpPr>
+      <p:grpSpPr>
+        <a:xfrm>
+          <a:off x="0" y="0"/>
+          <a:ext cx="0" cy="0"/>
+          <a:chOff x="0" y="0"/>
+          <a:chExt cx="0" cy="0"/>
+        </a:xfrm>
+      </p:grpSpPr>
+      <p:sp>
+        <p:nvSpPr>
+          <p:cNvPr id="2" name="Text 0"/>
+          <p:cNvSpPr/>
+          <p:nvPr/>
+        </p:nvSpPr>
+        <p:spPr>
+          <a:xfrm>
+            <a:off x="502920" y="274320"/>
+            <a:ext cx="8138160" cy="548640"/>
+          </a:xfrm>
+          <a:prstGeom prst="rect">
+            <a:avLst/>
+          </a:prstGeom>
+          <a:noFill/>
+          <a:ln/>
+        </p:spPr>
+        <p:txBody>
+          <a:bodyPr wrap="square" rtlCol="0" anchor="ctr"/>
+          <a:lstStyle/>
+          <a:p>
+            <a:pPr marL="0" indent="0" algn="l">
+              <a:buNone/>
+            </a:pPr>
+            <a:r>
+              <a:rPr lang="en-US" sz="2700" b="1" dirty="0">
+                <a:solidFill>
+                  <a:srgbClr val="1E293B"/>
+                </a:solidFill>
+                <a:latin typeface="Trebuchet MS" pitchFamily="34" charset="0"/>
+                <a:ea typeface="Trebuchet MS" pitchFamily="34" charset="-122"/>
+                <a:cs typeface="Trebuchet MS" pitchFamily="34" charset="-120"/>
+              </a:rPr>
+              <a:t>Additional resources</a:t>
+            </a:r>
+            <a:endParaRPr lang="en-US" sz="2700" dirty="0"/>
+          </a:p>
+        </p:txBody>
+      </p:sp>
+      <p:sp>
+        <p:nvSpPr>
+          <p:cNvPr id="3" name="Text 1"/>
+          <p:cNvSpPr/>
+          <p:nvPr/>
+        </p:nvSpPr>
+        <p:spPr>
+          <a:xfrm>
+            <a:off x="502920" y="841248"/>
+            <a:ext cx="8138160" cy="310896"/>
+          </a:xfrm>
+          <a:prstGeom prst="rect">
+            <a:avLst/>
+          </a:prstGeom>
+          <a:noFill/>
+          <a:ln/>
+        </p:spPr>
+        <p:txBody>
+          <a:bodyPr wrap="square" rtlCol="0" anchor="ctr"/>
+          <a:lstStyle/>
+          <a:p>
+            <a:pPr marL="0" indent="0" algn="l">
+              <a:buNone/>
+            </a:pPr>
+            <a:r>
+              <a:rPr lang="en-US" sz="1300" dirty="0">
+                <a:solidFill>
+                  <a:srgbClr val="64748B"/>
+                </a:solidFill>
+                <a:latin typeface="Calibri" pitchFamily="34" charset="0"/>
+                <a:ea typeface="Calibri" pitchFamily="34" charset="-122"/>
+                <a:cs typeface="Calibri" pitchFamily="34" charset="-120"/>
+              </a:rPr>
+              <a:t>More readings- more </a:t>
+            </a:r>
+            <a:r>
+              <a:rPr lang="en-US" sz="1300" dirty="0" err="1">
+                <a:solidFill>
+                  <a:srgbClr val="64748B"/>
+                </a:solidFill>
+                <a:latin typeface="Calibri" pitchFamily="34" charset="0"/>
+                <a:ea typeface="Calibri" pitchFamily="34" charset="-122"/>
+                <a:cs typeface="Calibri" pitchFamily="34" charset="-120"/>
+              </a:rPr>
+              <a:t>mfun</a:t>
+            </a:r>
+            <a:endParaRPr lang="en-US" sz="1300" dirty="0"/>
+          </a:p>
+        </p:txBody>
+      </p:sp>
+      <p:sp>
+        <p:nvSpPr>
+          <p:cNvPr id="5" name="Shape 3"/>
+          <p:cNvSpPr/>
+          <p:nvPr/>
+        </p:nvSpPr>
+        <p:spPr>
+          <a:xfrm>
+            <a:off x="502920" y="1371600"/>
+            <a:ext cx="8138160" cy="548640"/>
+          </a:xfrm>
+          <a:prstGeom prst="roundRect">
+            <a:avLst>
+              <a:gd name="adj" fmla="val 11667"/>
+            </a:avLst>
+          </a:prstGeom>
+          <a:solidFill>
+            <a:srgbClr val="FFFFFF"/>
+          </a:solidFill>
+          <a:ln w="9525">
+            <a:solidFill>
+              <a:srgbClr val="E2E8F0"/>
+            </a:solidFill>
+            <a:prstDash val="solid"/>
+          </a:ln>
+          <a:effectLst>
+            <a:outerShdw blurRad="76200" dist="38100" dir="5400000" algn="bl" rotWithShape="0">
+              <a:srgbClr val="000000">
+                <a:alpha val="10000"/>
+              </a:srgbClr>
+            </a:outerShdw>
+          </a:effectLst>
+        </p:spPr>
+        <p:txBody>
+          <a:bodyPr/>
+          <a:lstStyle/>
+          <a:p>
+            <a:endParaRPr lang="en-US"/>
+          </a:p>
+        </p:txBody>
+      </p:sp>
+      <p:sp>
+        <p:nvSpPr>
+          <p:cNvPr id="6" name="Shape 4"/>
+          <p:cNvSpPr/>
+          <p:nvPr/>
+        </p:nvSpPr>
+        <p:spPr>
+          <a:xfrm>
+            <a:off x="502920" y="1371600"/>
+            <a:ext cx="64008" cy="548640"/>
+          </a:xfrm>
+          <a:prstGeom prst="roundRect">
+            <a:avLst>
+              <a:gd name="adj" fmla="val 42857"/>
+            </a:avLst>
+          </a:prstGeom>
+          <a:solidFill>
+            <a:srgbClr val="FA5631"/>
+          </a:solidFill>
+          <a:ln/>
+        </p:spPr>
+        <p:txBody>
+          <a:bodyPr/>
+          <a:lstStyle/>
+          <a:p>
+            <a:endParaRPr lang="en-US"/>
+          </a:p>
+        </p:txBody>
+      </p:sp>
+      <p:sp>
+        <p:nvSpPr>
+          <p:cNvPr id="8" name="Text 6"/>
+          <p:cNvSpPr/>
+          <p:nvPr/>
+        </p:nvSpPr>
+        <p:spPr>
+          <a:xfrm>
+            <a:off x="731520" y="1453896"/>
+            <a:ext cx="384048" cy="384048"/>
+          </a:xfrm>
+          <a:prstGeom prst="rect">
+            <a:avLst/>
+          </a:prstGeom>
+          <a:noFill/>
+          <a:ln/>
+        </p:spPr>
+        <p:txBody>
+          <a:bodyPr wrap="square" rtlCol="0" anchor="ctr"/>
+          <a:lstStyle/>
+          <a:p>
+            <a:pPr marL="0" indent="0" algn="ctr">
+              <a:buNone/>
+            </a:pPr>
+            <a:r>
+              <a:rPr lang="en-US" sz="1800" b="1" dirty="0">
+                <a:solidFill>
+                  <a:srgbClr val="FFFFFF"/>
+                </a:solidFill>
+                <a:latin typeface="Calibri" pitchFamily="34" charset="0"/>
+                <a:ea typeface="Calibri" pitchFamily="34" charset="-122"/>
+                <a:cs typeface="Calibri" pitchFamily="34" charset="-120"/>
+              </a:rPr>
+              <a:t>⇄</a:t>
+            </a:r>
+            <a:endParaRPr lang="en-US" sz="1800" dirty="0"/>
+          </a:p>
+        </p:txBody>
+      </p:sp>
+      <p:sp>
+        <p:nvSpPr>
+          <p:cNvPr id="9" name="Text 7"/>
+          <p:cNvSpPr/>
+          <p:nvPr/>
+        </p:nvSpPr>
+        <p:spPr>
+          <a:xfrm>
+            <a:off x="1234440" y="1389888"/>
+            <a:ext cx="2880360" cy="512064"/>
+          </a:xfrm>
+          <a:prstGeom prst="rect">
+            <a:avLst/>
+          </a:prstGeom>
+          <a:noFill/>
+          <a:ln/>
+        </p:spPr>
+        <p:txBody>
+          <a:bodyPr wrap="square" rtlCol="0" anchor="ctr"/>
+          <a:lstStyle/>
+          <a:p>
+            <a:pPr marL="0" indent="0">
+              <a:buNone/>
+            </a:pPr>
+            <a:r>
+              <a:rPr lang="en-US" sz="1300" b="1" dirty="0" err="1">
+                <a:solidFill>
+                  <a:srgbClr val="1E293B"/>
+                </a:solidFill>
+                <a:latin typeface="Calibri" pitchFamily="34" charset="0"/>
+                <a:ea typeface="Calibri" pitchFamily="34" charset="-122"/>
+                <a:cs typeface="Calibri" pitchFamily="34" charset="-120"/>
+              </a:rPr>
+              <a:t>minceddata.net</a:t>
+            </a:r>
+            <a:endParaRPr lang="en-US" sz="1300" dirty="0"/>
+          </a:p>
+        </p:txBody>
+      </p:sp>
+      <p:sp>
+        <p:nvSpPr>
+          <p:cNvPr id="10" name="Text 8"/>
+          <p:cNvSpPr/>
+          <p:nvPr/>
+        </p:nvSpPr>
+        <p:spPr>
+          <a:xfrm>
+            <a:off x="4206240" y="1389888"/>
+            <a:ext cx="4251960" cy="512064"/>
+          </a:xfrm>
+          <a:prstGeom prst="rect">
+            <a:avLst/>
+          </a:prstGeom>
+          <a:noFill/>
+          <a:ln/>
+        </p:spPr>
+        <p:txBody>
+          <a:bodyPr wrap="square" rtlCol="0" anchor="ctr"/>
+          <a:lstStyle/>
+          <a:p>
+            <a:r>
+              <a:rPr lang="en-US" sz="1100" dirty="0">
+                <a:solidFill>
+                  <a:srgbClr val="64748B"/>
+                </a:solidFill>
+                <a:latin typeface="Calibri" pitchFamily="34" charset="0"/>
+                <a:ea typeface="Calibri" pitchFamily="34" charset="-122"/>
+                <a:cs typeface="Calibri" pitchFamily="34" charset="-120"/>
+              </a:rPr>
+              <a:t>My blog, with a growing series of the knowledge hub:</a:t>
+            </a:r>
+            <a:br>
+              <a:rPr lang="en-US" sz="1100" dirty="0">
+                <a:solidFill>
+                  <a:srgbClr val="64748B"/>
+                </a:solidFill>
+                <a:latin typeface="Calibri" pitchFamily="34" charset="0"/>
+                <a:ea typeface="Calibri" pitchFamily="34" charset="-122"/>
+                <a:cs typeface="Calibri" pitchFamily="34" charset="-120"/>
+              </a:rPr>
+            </a:br>
+            <a:r>
+              <a:rPr lang="en-US" sz="1100" dirty="0">
+                <a:solidFill>
+                  <a:srgbClr val="64748B"/>
+                </a:solidFill>
+                <a:latin typeface="Calibri" pitchFamily="34" charset="0"/>
+                <a:ea typeface="Calibri" pitchFamily="34" charset="-122"/>
+                <a:cs typeface="Calibri" pitchFamily="34" charset="-120"/>
+              </a:rPr>
+              <a:t>https://</a:t>
+            </a:r>
+            <a:r>
+              <a:rPr lang="en-US" sz="1100" dirty="0" err="1">
+                <a:solidFill>
+                  <a:srgbClr val="64748B"/>
+                </a:solidFill>
+                <a:latin typeface="Calibri" pitchFamily="34" charset="0"/>
+                <a:ea typeface="Calibri" pitchFamily="34" charset="-122"/>
+                <a:cs typeface="Calibri" pitchFamily="34" charset="-120"/>
+              </a:rPr>
+              <a:t>minceddata.net</a:t>
+            </a:r>
+            <a:r>
+              <a:rPr lang="en-US" sz="1100" dirty="0">
+                <a:solidFill>
+                  <a:srgbClr val="64748B"/>
+                </a:solidFill>
+                <a:latin typeface="Calibri" pitchFamily="34" charset="0"/>
+                <a:ea typeface="Calibri" pitchFamily="34" charset="-122"/>
+                <a:cs typeface="Calibri" pitchFamily="34" charset="-120"/>
+              </a:rPr>
+              <a:t>/</a:t>
+            </a:r>
+            <a:r>
+              <a:rPr lang="en-US" sz="1100" dirty="0" err="1">
+                <a:solidFill>
+                  <a:srgbClr val="64748B"/>
+                </a:solidFill>
+                <a:latin typeface="Calibri" pitchFamily="34" charset="0"/>
+                <a:ea typeface="Calibri" pitchFamily="34" charset="-122"/>
+                <a:cs typeface="Calibri" pitchFamily="34" charset="-120"/>
+              </a:rPr>
+              <a:t>The+knowledge+hub</a:t>
+            </a:r>
+            <a:r>
+              <a:rPr lang="en-US" sz="1100" dirty="0">
+                <a:solidFill>
+                  <a:srgbClr val="64748B"/>
+                </a:solidFill>
+                <a:latin typeface="Calibri" pitchFamily="34" charset="0"/>
+                <a:ea typeface="Calibri" pitchFamily="34" charset="-122"/>
+                <a:cs typeface="Calibri" pitchFamily="34" charset="-120"/>
+              </a:rPr>
+              <a:t>/</a:t>
+            </a:r>
+            <a:r>
+              <a:rPr lang="en-US" sz="1100" dirty="0" err="1">
+                <a:solidFill>
+                  <a:srgbClr val="64748B"/>
+                </a:solidFill>
+                <a:latin typeface="Calibri" pitchFamily="34" charset="0"/>
+                <a:ea typeface="Calibri" pitchFamily="34" charset="-122"/>
+                <a:cs typeface="Calibri" pitchFamily="34" charset="-120"/>
+              </a:rPr>
+              <a:t>Building+a+Personal+Knowledge+Hub</a:t>
+            </a:r>
+            <a:endParaRPr lang="en-US" sz="1100" dirty="0"/>
+          </a:p>
+        </p:txBody>
+      </p:sp>
+      <p:sp>
+        <p:nvSpPr>
+          <p:cNvPr id="11" name="Shape 9"/>
+          <p:cNvSpPr/>
+          <p:nvPr/>
+        </p:nvSpPr>
+        <p:spPr>
+          <a:xfrm>
+            <a:off x="502920" y="2048256"/>
+            <a:ext cx="8138160" cy="548640"/>
+          </a:xfrm>
+          <a:prstGeom prst="roundRect">
+            <a:avLst>
+              <a:gd name="adj" fmla="val 11667"/>
+            </a:avLst>
+          </a:prstGeom>
+          <a:solidFill>
+            <a:srgbClr val="FFFFFF"/>
+          </a:solidFill>
+          <a:ln w="9525">
+            <a:solidFill>
+              <a:srgbClr val="E2E8F0"/>
+            </a:solidFill>
+            <a:prstDash val="solid"/>
+          </a:ln>
+          <a:effectLst>
+            <a:outerShdw blurRad="76200" dist="38100" dir="5400000" algn="bl" rotWithShape="0">
+              <a:srgbClr val="000000">
+                <a:alpha val="10000"/>
+              </a:srgbClr>
+            </a:outerShdw>
+          </a:effectLst>
+        </p:spPr>
+        <p:txBody>
+          <a:bodyPr/>
+          <a:lstStyle/>
+          <a:p>
+            <a:endParaRPr lang="en-US"/>
+          </a:p>
+        </p:txBody>
+      </p:sp>
+      <p:sp>
+        <p:nvSpPr>
+          <p:cNvPr id="12" name="Shape 10"/>
+          <p:cNvSpPr/>
+          <p:nvPr/>
+        </p:nvSpPr>
+        <p:spPr>
+          <a:xfrm>
+            <a:off x="502920" y="2048256"/>
+            <a:ext cx="64008" cy="548640"/>
+          </a:xfrm>
+          <a:prstGeom prst="roundRect">
+            <a:avLst>
+              <a:gd name="adj" fmla="val 42857"/>
+            </a:avLst>
+          </a:prstGeom>
+          <a:solidFill>
+            <a:srgbClr val="44D7DE"/>
+          </a:solidFill>
+          <a:ln/>
+        </p:spPr>
+        <p:txBody>
+          <a:bodyPr/>
+          <a:lstStyle/>
+          <a:p>
+            <a:endParaRPr lang="en-US"/>
+          </a:p>
+        </p:txBody>
+      </p:sp>
+      <p:sp>
+        <p:nvSpPr>
+          <p:cNvPr id="14" name="Text 12"/>
+          <p:cNvSpPr/>
+          <p:nvPr/>
+        </p:nvSpPr>
+        <p:spPr>
+          <a:xfrm>
+            <a:off x="731520" y="2130552"/>
+            <a:ext cx="384048" cy="384048"/>
+          </a:xfrm>
+          <a:prstGeom prst="rect">
+            <a:avLst/>
+          </a:prstGeom>
+          <a:noFill/>
+          <a:ln/>
+        </p:spPr>
+        <p:txBody>
+          <a:bodyPr wrap="square" rtlCol="0" anchor="ctr"/>
+          <a:lstStyle/>
+          <a:p>
+            <a:pPr marL="0" indent="0" algn="ctr">
+              <a:buNone/>
+            </a:pPr>
+            <a:endParaRPr lang="en-US" sz="1800" dirty="0"/>
+          </a:p>
+        </p:txBody>
+      </p:sp>
+      <p:sp>
+        <p:nvSpPr>
+          <p:cNvPr id="15" name="Text 13"/>
+          <p:cNvSpPr/>
+          <p:nvPr/>
+        </p:nvSpPr>
+        <p:spPr>
+          <a:xfrm>
+            <a:off x="1234440" y="2066544"/>
+            <a:ext cx="2880360" cy="512064"/>
+          </a:xfrm>
+          <a:prstGeom prst="rect">
+            <a:avLst/>
+          </a:prstGeom>
+          <a:noFill/>
+          <a:ln/>
+        </p:spPr>
+        <p:txBody>
+          <a:bodyPr wrap="square" rtlCol="0" anchor="ctr"/>
+          <a:lstStyle/>
+          <a:p>
+            <a:pPr marL="0" indent="0">
+              <a:buNone/>
+            </a:pPr>
+            <a:r>
+              <a:rPr lang="en-US" sz="1300" b="1" dirty="0" err="1">
+                <a:solidFill>
+                  <a:srgbClr val="1E293B"/>
+                </a:solidFill>
+                <a:latin typeface="Calibri" pitchFamily="34" charset="0"/>
+                <a:ea typeface="Calibri" pitchFamily="34" charset="-122"/>
+                <a:cs typeface="Calibri" pitchFamily="34" charset="-120"/>
+              </a:rPr>
+              <a:t>Github</a:t>
+            </a:r>
+            <a:r>
+              <a:rPr lang="en-US" sz="1300" b="1" dirty="0">
+                <a:solidFill>
+                  <a:srgbClr val="1E293B"/>
+                </a:solidFill>
+                <a:latin typeface="Calibri" pitchFamily="34" charset="0"/>
+                <a:ea typeface="Calibri" pitchFamily="34" charset="-122"/>
+                <a:cs typeface="Calibri" pitchFamily="34" charset="-120"/>
+              </a:rPr>
+              <a:t> repo</a:t>
+            </a:r>
+            <a:endParaRPr lang="en-US" sz="1300" dirty="0"/>
+          </a:p>
+        </p:txBody>
+      </p:sp>
+      <p:sp>
+        <p:nvSpPr>
+          <p:cNvPr id="16" name="Text 14"/>
+          <p:cNvSpPr/>
+          <p:nvPr/>
+        </p:nvSpPr>
+        <p:spPr>
+          <a:xfrm>
+            <a:off x="4206240" y="2066544"/>
+            <a:ext cx="4251960" cy="512064"/>
+          </a:xfrm>
+          <a:prstGeom prst="rect">
+            <a:avLst/>
+          </a:prstGeom>
+          <a:noFill/>
+          <a:ln/>
+        </p:spPr>
+        <p:txBody>
+          <a:bodyPr wrap="square" rtlCol="0" anchor="ctr"/>
+          <a:lstStyle/>
+          <a:p>
+            <a:pPr marL="0" indent="0">
+              <a:lnSpc>
+                <a:spcPct val="100000"/>
+              </a:lnSpc>
+              <a:buNone/>
+            </a:pPr>
+            <a:r>
+              <a:rPr lang="en-US" sz="1100" dirty="0">
+                <a:solidFill>
+                  <a:srgbClr val="64748B"/>
+                </a:solidFill>
+                <a:latin typeface="Calibri" pitchFamily="34" charset="0"/>
+                <a:ea typeface="Calibri" pitchFamily="34" charset="-122"/>
+                <a:cs typeface="Calibri" pitchFamily="34" charset="-120"/>
+              </a:rPr>
+              <a:t>My public  repo that helps to get you started with </a:t>
+            </a:r>
+            <a:r>
+              <a:rPr lang="en-US" sz="1100" dirty="0" err="1">
+                <a:solidFill>
+                  <a:srgbClr val="64748B"/>
+                </a:solidFill>
+                <a:latin typeface="Calibri" pitchFamily="34" charset="0"/>
+                <a:ea typeface="Calibri" pitchFamily="34" charset="-122"/>
+                <a:cs typeface="Calibri" pitchFamily="34" charset="-120"/>
+              </a:rPr>
+              <a:t>rss</a:t>
+            </a:r>
+            <a:r>
+              <a:rPr lang="en-US" sz="1100" dirty="0">
+                <a:solidFill>
+                  <a:srgbClr val="64748B"/>
+                </a:solidFill>
+                <a:latin typeface="Calibri" pitchFamily="34" charset="0"/>
+                <a:ea typeface="Calibri" pitchFamily="34" charset="-122"/>
+                <a:cs typeface="Calibri" pitchFamily="34" charset="-120"/>
+              </a:rPr>
+              <a:t>-based articles:</a:t>
+            </a:r>
+          </a:p>
+          <a:p>
+            <a:r>
+              <a:rPr lang="en-US" sz="1100" dirty="0">
+                <a:solidFill>
+                  <a:srgbClr val="64748B"/>
+                </a:solidFill>
+                <a:latin typeface="Calibri" pitchFamily="34" charset="0"/>
+                <a:cs typeface="Calibri" pitchFamily="34" charset="-120"/>
+              </a:rPr>
+              <a:t>https://</a:t>
+            </a:r>
+            <a:r>
+              <a:rPr lang="en-US" sz="1100" dirty="0" err="1">
+                <a:solidFill>
+                  <a:srgbClr val="64748B"/>
+                </a:solidFill>
+                <a:latin typeface="Calibri" pitchFamily="34" charset="0"/>
+                <a:cs typeface="Calibri" pitchFamily="34" charset="-120"/>
+              </a:rPr>
+              <a:t>github.com</a:t>
+            </a:r>
+            <a:r>
+              <a:rPr lang="en-US" sz="1100" dirty="0">
+                <a:solidFill>
+                  <a:srgbClr val="64748B"/>
+                </a:solidFill>
+                <a:latin typeface="Calibri" pitchFamily="34" charset="0"/>
+                <a:cs typeface="Calibri" pitchFamily="34" charset="-120"/>
+              </a:rPr>
+              <a:t>/</a:t>
+            </a:r>
+            <a:r>
+              <a:rPr lang="en-US" sz="1100" dirty="0" err="1">
+                <a:solidFill>
+                  <a:srgbClr val="64748B"/>
+                </a:solidFill>
+                <a:latin typeface="Calibri" pitchFamily="34" charset="0"/>
+                <a:cs typeface="Calibri" pitchFamily="34" charset="-120"/>
+              </a:rPr>
+              <a:t>tomatminceddata</a:t>
+            </a:r>
+            <a:r>
+              <a:rPr lang="en-US" sz="1100" dirty="0">
+                <a:solidFill>
+                  <a:srgbClr val="64748B"/>
+                </a:solidFill>
+                <a:latin typeface="Calibri" pitchFamily="34" charset="0"/>
+                <a:cs typeface="Calibri" pitchFamily="34" charset="-120"/>
+              </a:rPr>
+              <a:t>/RSS-feed-sync</a:t>
+            </a:r>
+          </a:p>
+        </p:txBody>
+      </p:sp>
+      <p:sp>
+        <p:nvSpPr>
+          <p:cNvPr id="35" name="Text 33"/>
+          <p:cNvSpPr/>
+          <p:nvPr/>
+        </p:nvSpPr>
+        <p:spPr>
+          <a:xfrm>
+            <a:off x="7982520" y="4828032"/>
+            <a:ext cx="750000" cy="256032"/>
+          </a:xfrm>
+          <a:prstGeom prst="rect">
+            <a:avLst/>
+          </a:prstGeom>
+          <a:noFill/>
+          <a:ln/>
+        </p:spPr>
+        <p:txBody>
+          <a:bodyPr wrap="square" rtlCol="0" anchor="ctr"/>
+          <a:lstStyle/>
+          <a:p>
+            <a:pPr marL="0" indent="0" algn="r">
+              <a:buNone/>
+            </a:pPr>
+            <a:r>
+              <a:rPr lang="en-US" sz="900" dirty="0">
+                <a:solidFill>
+                  <a:srgbClr val="94A3B8"/>
+                </a:solidFill>
+                <a:latin typeface="Calibri" pitchFamily="34" charset="0"/>
+                <a:ea typeface="Calibri" pitchFamily="34" charset="-122"/>
+                <a:cs typeface="Calibri" pitchFamily="34" charset="-120"/>
+              </a:rPr>
+              <a:t>Glossary</a:t>
+            </a:r>
+            <a:endParaRPr lang="en-US" sz="900" dirty="0"/>
+          </a:p>
+        </p:txBody>
+      </p:sp>
+      <p:pic>
+        <p:nvPicPr>
+          <p:cNvPr id="36" name="Picture 35">
+            <a:hlinkClick r:id="rId2"/>
+            <a:extLst>
+              <a:ext uri="{FF2B5EF4-FFF2-40B4-BE49-F238E27FC236}">
+                <a16:creationId xmlns:a16="http://schemas.microsoft.com/office/drawing/2014/main" id="{951B7387-96F9-8B9B-313F-106C259AF2A9}"/>
+              </a:ext>
+            </a:extLst>
+          </p:cNvPr>
+          <p:cNvPicPr>
+            <a:picLocks noChangeAspect="1"/>
+          </p:cNvPicPr>
+          <p:nvPr/>
+        </p:nvPicPr>
+        <p:blipFill>
+          <a:blip r:embed="rId3"/>
+          <a:stretch>
+            <a:fillRect/>
+          </a:stretch>
+        </p:blipFill>
+        <p:spPr>
+          <a:xfrm>
+            <a:off x="594839" y="1408716"/>
+            <a:ext cx="484632" cy="469487"/>
+          </a:xfrm>
+          <a:prstGeom prst="rect">
+            <a:avLst/>
+          </a:prstGeom>
+        </p:spPr>
+      </p:pic>
+      <p:pic>
+        <p:nvPicPr>
+          <p:cNvPr id="37" name="Picture 36" descr="Image result for GitHub Logo Download">
+            <a:hlinkClick r:id="rId4"/>
+            <a:extLst>
+              <a:ext uri="{FF2B5EF4-FFF2-40B4-BE49-F238E27FC236}">
+                <a16:creationId xmlns:a16="http://schemas.microsoft.com/office/drawing/2014/main" id="{54D1CB71-31AD-2832-52BB-AEC8018E7211}"/>
+              </a:ext>
+            </a:extLst>
+          </p:cNvPr>
+          <p:cNvPicPr>
+            <a:picLocks noChangeAspect="1"/>
+          </p:cNvPicPr>
+          <p:nvPr/>
+        </p:nvPicPr>
+        <p:blipFill>
+          <a:blip r:embed="rId5"/>
+          <a:stretch>
+            <a:fillRect/>
+          </a:stretch>
+        </p:blipFill>
+        <p:spPr>
+          <a:xfrm>
+            <a:off x="581123" y="2093124"/>
+            <a:ext cx="512064" cy="512064"/>
+          </a:xfrm>
+          <a:prstGeom prst="rect">
+            <a:avLst/>
+          </a:prstGeom>
+        </p:spPr>
+      </p:pic>
+    </p:spTree>
+  </p:cSld>
+  <p:clrMapOvr>
+    <a:masterClrMapping/>
+  </p:clrMapOvr>
+</p:sld>
+</file>
+
+<file path=ppt/slides/slide24.xml><?xml version="1.0" encoding="utf-8"?>
+<p:sld xmlns:a="http://schemas.openxmlformats.org/drawingml/2006/main" xmlns:r="http://schemas.openxmlformats.org/officeDocument/2006/relationships" xmlns:p="http://schemas.openxmlformats.org/presentationml/2006/main">
   <p:cSld name="Slide 20">
     <p:bg>
       <p:bgPr>
@@ -14103,1251 +14842,6 @@
           <a:lstStyle/>
           <a:p>
             <a:endParaRPr lang="en-US"/>
-          </a:p>
-        </p:txBody>
-      </p:sp>
-    </p:spTree>
-  </p:cSld>
-  <p:clrMapOvr>
-    <a:masterClrMapping/>
-  </p:clrMapOvr>
-</p:sld>
-</file>
-
-<file path=ppt/slides/slide24.xml><?xml version="1.0" encoding="utf-8"?>
-<p:sld xmlns:a="http://schemas.openxmlformats.org/drawingml/2006/main" xmlns:r="http://schemas.openxmlformats.org/officeDocument/2006/relationships" xmlns:p="http://schemas.openxmlformats.org/presentationml/2006/main">
-  <p:cSld name="Slide 17">
-    <p:bg>
-      <p:bgPr>
-        <a:solidFill>
-          <a:srgbClr val="F8FAFC"/>
-        </a:solidFill>
-        <a:effectLst/>
-      </p:bgPr>
-    </p:bg>
-    <p:spTree>
-      <p:nvGrpSpPr>
-        <p:cNvPr id="1" name=""/>
-        <p:cNvGrpSpPr/>
-        <p:nvPr/>
-      </p:nvGrpSpPr>
-      <p:grpSpPr>
-        <a:xfrm>
-          <a:off x="0" y="0"/>
-          <a:ext cx="0" cy="0"/>
-          <a:chOff x="0" y="0"/>
-          <a:chExt cx="0" cy="0"/>
-        </a:xfrm>
-      </p:grpSpPr>
-      <p:sp>
-        <p:nvSpPr>
-          <p:cNvPr id="2" name="Text 0"/>
-          <p:cNvSpPr/>
-          <p:nvPr/>
-        </p:nvSpPr>
-        <p:spPr>
-          <a:xfrm>
-            <a:off x="502920" y="274320"/>
-            <a:ext cx="8138160" cy="548640"/>
-          </a:xfrm>
-          <a:prstGeom prst="rect">
-            <a:avLst/>
-          </a:prstGeom>
-          <a:noFill/>
-          <a:ln/>
-        </p:spPr>
-        <p:txBody>
-          <a:bodyPr wrap="square" rtlCol="0" anchor="ctr"/>
-          <a:lstStyle/>
-          <a:p>
-            <a:pPr marL="0" indent="0" algn="l">
-              <a:buNone/>
-            </a:pPr>
-            <a:r>
-              <a:rPr lang="en-US" sz="2700" b="1" dirty="0">
-                <a:solidFill>
-                  <a:srgbClr val="1E293B"/>
-                </a:solidFill>
-                <a:latin typeface="Trebuchet MS" pitchFamily="34" charset="0"/>
-                <a:ea typeface="Trebuchet MS" pitchFamily="34" charset="-122"/>
-                <a:cs typeface="Trebuchet MS" pitchFamily="34" charset="-120"/>
-              </a:rPr>
-              <a:t>Glossary — the retrieval side</a:t>
-            </a:r>
-            <a:endParaRPr lang="en-US" sz="2700" dirty="0"/>
-          </a:p>
-        </p:txBody>
-      </p:sp>
-      <p:sp>
-        <p:nvSpPr>
-          <p:cNvPr id="3" name="Text 1"/>
-          <p:cNvSpPr/>
-          <p:nvPr/>
-        </p:nvSpPr>
-        <p:spPr>
-          <a:xfrm>
-            <a:off x="502920" y="841248"/>
-            <a:ext cx="8138160" cy="310896"/>
-          </a:xfrm>
-          <a:prstGeom prst="rect">
-            <a:avLst/>
-          </a:prstGeom>
-          <a:noFill/>
-          <a:ln/>
-        </p:spPr>
-        <p:txBody>
-          <a:bodyPr wrap="square" rtlCol="0" anchor="ctr"/>
-          <a:lstStyle/>
-          <a:p>
-            <a:pPr marL="0" indent="0" algn="l">
-              <a:buNone/>
-            </a:pPr>
-            <a:r>
-              <a:rPr lang="en-US" sz="1300" dirty="0">
-                <a:solidFill>
-                  <a:srgbClr val="64748B"/>
-                </a:solidFill>
-                <a:latin typeface="Calibri" pitchFamily="34" charset="0"/>
-                <a:ea typeface="Calibri" pitchFamily="34" charset="-122"/>
-                <a:cs typeface="Calibri" pitchFamily="34" charset="-120"/>
-              </a:rPr>
-              <a:t>The ideas behind the rabbit holes — none of it Fabric-specific</a:t>
-            </a:r>
-            <a:endParaRPr lang="en-US" sz="1300" dirty="0"/>
-          </a:p>
-        </p:txBody>
-      </p:sp>
-      <p:sp>
-        <p:nvSpPr>
-          <p:cNvPr id="5" name="Shape 3"/>
-          <p:cNvSpPr/>
-          <p:nvPr/>
-        </p:nvSpPr>
-        <p:spPr>
-          <a:xfrm>
-            <a:off x="502920" y="1371600"/>
-            <a:ext cx="8138160" cy="548640"/>
-          </a:xfrm>
-          <a:prstGeom prst="roundRect">
-            <a:avLst>
-              <a:gd name="adj" fmla="val 11667"/>
-            </a:avLst>
-          </a:prstGeom>
-          <a:solidFill>
-            <a:srgbClr val="FFFFFF"/>
-          </a:solidFill>
-          <a:ln w="9525">
-            <a:solidFill>
-              <a:srgbClr val="E2E8F0"/>
-            </a:solidFill>
-            <a:prstDash val="solid"/>
-          </a:ln>
-          <a:effectLst>
-            <a:outerShdw blurRad="76200" dist="38100" dir="5400000" algn="bl" rotWithShape="0">
-              <a:srgbClr val="000000">
-                <a:alpha val="10000"/>
-              </a:srgbClr>
-            </a:outerShdw>
-          </a:effectLst>
-        </p:spPr>
-        <p:txBody>
-          <a:bodyPr/>
-          <a:lstStyle/>
-          <a:p>
-            <a:endParaRPr lang="en-US"/>
-          </a:p>
-        </p:txBody>
-      </p:sp>
-      <p:sp>
-        <p:nvSpPr>
-          <p:cNvPr id="6" name="Shape 4"/>
-          <p:cNvSpPr/>
-          <p:nvPr/>
-        </p:nvSpPr>
-        <p:spPr>
-          <a:xfrm>
-            <a:off x="502920" y="1371600"/>
-            <a:ext cx="64008" cy="548640"/>
-          </a:xfrm>
-          <a:prstGeom prst="roundRect">
-            <a:avLst>
-              <a:gd name="adj" fmla="val 42857"/>
-            </a:avLst>
-          </a:prstGeom>
-          <a:solidFill>
-            <a:srgbClr val="0D9488"/>
-          </a:solidFill>
-          <a:ln/>
-        </p:spPr>
-        <p:txBody>
-          <a:bodyPr/>
-          <a:lstStyle/>
-          <a:p>
-            <a:endParaRPr lang="en-US"/>
-          </a:p>
-        </p:txBody>
-      </p:sp>
-      <p:sp>
-        <p:nvSpPr>
-          <p:cNvPr id="7" name="Shape 5"/>
-          <p:cNvSpPr/>
-          <p:nvPr/>
-        </p:nvSpPr>
-        <p:spPr>
-          <a:xfrm>
-            <a:off x="731520" y="1453896"/>
-            <a:ext cx="384048" cy="384048"/>
-          </a:xfrm>
-          <a:prstGeom prst="roundRect">
-            <a:avLst>
-              <a:gd name="adj" fmla="val 16667"/>
-            </a:avLst>
-          </a:prstGeom>
-          <a:solidFill>
-            <a:srgbClr val="0D9488"/>
-          </a:solidFill>
-          <a:ln/>
-        </p:spPr>
-        <p:txBody>
-          <a:bodyPr/>
-          <a:lstStyle/>
-          <a:p>
-            <a:endParaRPr lang="en-US"/>
-          </a:p>
-        </p:txBody>
-      </p:sp>
-      <p:sp>
-        <p:nvSpPr>
-          <p:cNvPr id="8" name="Text 6"/>
-          <p:cNvSpPr/>
-          <p:nvPr/>
-        </p:nvSpPr>
-        <p:spPr>
-          <a:xfrm>
-            <a:off x="731520" y="1453896"/>
-            <a:ext cx="384048" cy="384048"/>
-          </a:xfrm>
-          <a:prstGeom prst="rect">
-            <a:avLst/>
-          </a:prstGeom>
-          <a:noFill/>
-          <a:ln/>
-        </p:spPr>
-        <p:txBody>
-          <a:bodyPr wrap="square" rtlCol="0" anchor="ctr"/>
-          <a:lstStyle/>
-          <a:p>
-            <a:pPr marL="0" indent="0" algn="ctr">
-              <a:buNone/>
-            </a:pPr>
-            <a:r>
-              <a:rPr lang="en-US" sz="1800" b="1" dirty="0">
-                <a:solidFill>
-                  <a:srgbClr val="FFFFFF"/>
-                </a:solidFill>
-                <a:latin typeface="Calibri" pitchFamily="34" charset="0"/>
-                <a:ea typeface="Calibri" pitchFamily="34" charset="-122"/>
-                <a:cs typeface="Calibri" pitchFamily="34" charset="-120"/>
-              </a:rPr>
-              <a:t>⇄</a:t>
-            </a:r>
-            <a:endParaRPr lang="en-US" sz="1800" dirty="0"/>
-          </a:p>
-        </p:txBody>
-      </p:sp>
-      <p:sp>
-        <p:nvSpPr>
-          <p:cNvPr id="9" name="Text 7"/>
-          <p:cNvSpPr/>
-          <p:nvPr/>
-        </p:nvSpPr>
-        <p:spPr>
-          <a:xfrm>
-            <a:off x="1234440" y="1389888"/>
-            <a:ext cx="2880360" cy="512064"/>
-          </a:xfrm>
-          <a:prstGeom prst="rect">
-            <a:avLst/>
-          </a:prstGeom>
-          <a:noFill/>
-          <a:ln/>
-        </p:spPr>
-        <p:txBody>
-          <a:bodyPr wrap="square" rtlCol="0" anchor="ctr"/>
-          <a:lstStyle/>
-          <a:p>
-            <a:pPr marL="0" indent="0">
-              <a:buNone/>
-            </a:pPr>
-            <a:r>
-              <a:rPr lang="en-US" sz="1300" b="1" dirty="0">
-                <a:solidFill>
-                  <a:srgbClr val="1E293B"/>
-                </a:solidFill>
-                <a:latin typeface="Calibri" pitchFamily="34" charset="0"/>
-                <a:ea typeface="Calibri" pitchFamily="34" charset="-122"/>
-                <a:cs typeface="Calibri" pitchFamily="34" charset="-120"/>
-              </a:rPr>
-              <a:t>Embedding</a:t>
-            </a:r>
-            <a:endParaRPr lang="en-US" sz="1300" dirty="0"/>
-          </a:p>
-        </p:txBody>
-      </p:sp>
-      <p:sp>
-        <p:nvSpPr>
-          <p:cNvPr id="10" name="Text 8"/>
-          <p:cNvSpPr/>
-          <p:nvPr/>
-        </p:nvSpPr>
-        <p:spPr>
-          <a:xfrm>
-            <a:off x="4206240" y="1389888"/>
-            <a:ext cx="4251960" cy="512064"/>
-          </a:xfrm>
-          <a:prstGeom prst="rect">
-            <a:avLst/>
-          </a:prstGeom>
-          <a:noFill/>
-          <a:ln/>
-        </p:spPr>
-        <p:txBody>
-          <a:bodyPr wrap="square" rtlCol="0" anchor="ctr"/>
-          <a:lstStyle/>
-          <a:p>
-            <a:pPr marL="0" indent="0">
-              <a:lnSpc>
-                <a:spcPct val="100000"/>
-              </a:lnSpc>
-              <a:buNone/>
-            </a:pPr>
-            <a:r>
-              <a:rPr lang="en-US" sz="1100" dirty="0">
-                <a:solidFill>
-                  <a:srgbClr val="64748B"/>
-                </a:solidFill>
-                <a:latin typeface="Calibri" pitchFamily="34" charset="0"/>
-                <a:ea typeface="Calibri" pitchFamily="34" charset="-122"/>
-                <a:cs typeface="Calibri" pitchFamily="34" charset="-120"/>
-              </a:rPr>
-              <a:t>Text turned into a list of numbers that captures its meaning, so similar ideas sit close together in space.</a:t>
-            </a:r>
-            <a:endParaRPr lang="en-US" sz="1100" dirty="0"/>
-          </a:p>
-        </p:txBody>
-      </p:sp>
-      <p:sp>
-        <p:nvSpPr>
-          <p:cNvPr id="11" name="Shape 9"/>
-          <p:cNvSpPr/>
-          <p:nvPr/>
-        </p:nvSpPr>
-        <p:spPr>
-          <a:xfrm>
-            <a:off x="502920" y="2048256"/>
-            <a:ext cx="8138160" cy="548640"/>
-          </a:xfrm>
-          <a:prstGeom prst="roundRect">
-            <a:avLst>
-              <a:gd name="adj" fmla="val 11667"/>
-            </a:avLst>
-          </a:prstGeom>
-          <a:solidFill>
-            <a:srgbClr val="FFFFFF"/>
-          </a:solidFill>
-          <a:ln w="9525">
-            <a:solidFill>
-              <a:srgbClr val="E2E8F0"/>
-            </a:solidFill>
-            <a:prstDash val="solid"/>
-          </a:ln>
-          <a:effectLst>
-            <a:outerShdw blurRad="76200" dist="38100" dir="5400000" algn="bl" rotWithShape="0">
-              <a:srgbClr val="000000">
-                <a:alpha val="10000"/>
-              </a:srgbClr>
-            </a:outerShdw>
-          </a:effectLst>
-        </p:spPr>
-        <p:txBody>
-          <a:bodyPr/>
-          <a:lstStyle/>
-          <a:p>
-            <a:endParaRPr lang="en-US"/>
-          </a:p>
-        </p:txBody>
-      </p:sp>
-      <p:sp>
-        <p:nvSpPr>
-          <p:cNvPr id="12" name="Shape 10"/>
-          <p:cNvSpPr/>
-          <p:nvPr/>
-        </p:nvSpPr>
-        <p:spPr>
-          <a:xfrm>
-            <a:off x="502920" y="2048256"/>
-            <a:ext cx="64008" cy="548640"/>
-          </a:xfrm>
-          <a:prstGeom prst="roundRect">
-            <a:avLst>
-              <a:gd name="adj" fmla="val 42857"/>
-            </a:avLst>
-          </a:prstGeom>
-          <a:solidFill>
-            <a:srgbClr val="FF6348"/>
-          </a:solidFill>
-          <a:ln/>
-        </p:spPr>
-        <p:txBody>
-          <a:bodyPr/>
-          <a:lstStyle/>
-          <a:p>
-            <a:endParaRPr lang="en-US"/>
-          </a:p>
-        </p:txBody>
-      </p:sp>
-      <p:sp>
-        <p:nvSpPr>
-          <p:cNvPr id="13" name="Shape 11"/>
-          <p:cNvSpPr/>
-          <p:nvPr/>
-        </p:nvSpPr>
-        <p:spPr>
-          <a:xfrm>
-            <a:off x="731520" y="2130552"/>
-            <a:ext cx="384048" cy="384048"/>
-          </a:xfrm>
-          <a:prstGeom prst="roundRect">
-            <a:avLst>
-              <a:gd name="adj" fmla="val 16667"/>
-            </a:avLst>
-          </a:prstGeom>
-          <a:solidFill>
-            <a:srgbClr val="FF6348"/>
-          </a:solidFill>
-          <a:ln/>
-        </p:spPr>
-        <p:txBody>
-          <a:bodyPr/>
-          <a:lstStyle/>
-          <a:p>
-            <a:endParaRPr lang="en-US"/>
-          </a:p>
-        </p:txBody>
-      </p:sp>
-      <p:sp>
-        <p:nvSpPr>
-          <p:cNvPr id="14" name="Text 12"/>
-          <p:cNvSpPr/>
-          <p:nvPr/>
-        </p:nvSpPr>
-        <p:spPr>
-          <a:xfrm>
-            <a:off x="731520" y="2130552"/>
-            <a:ext cx="384048" cy="384048"/>
-          </a:xfrm>
-          <a:prstGeom prst="rect">
-            <a:avLst/>
-          </a:prstGeom>
-          <a:noFill/>
-          <a:ln/>
-        </p:spPr>
-        <p:txBody>
-          <a:bodyPr wrap="square" rtlCol="0" anchor="ctr"/>
-          <a:lstStyle/>
-          <a:p>
-            <a:pPr marL="0" indent="0" algn="ctr">
-              <a:buNone/>
-            </a:pPr>
-            <a:r>
-              <a:rPr lang="en-US" sz="1800" b="1" dirty="0">
-                <a:solidFill>
-                  <a:srgbClr val="FFFFFF"/>
-                </a:solidFill>
-                <a:latin typeface="Calibri" pitchFamily="34" charset="0"/>
-                <a:ea typeface="Calibri" pitchFamily="34" charset="-122"/>
-                <a:cs typeface="Calibri" pitchFamily="34" charset="-120"/>
-              </a:rPr>
-              <a:t>⚙</a:t>
-            </a:r>
-            <a:endParaRPr lang="en-US" sz="1800" dirty="0"/>
-          </a:p>
-        </p:txBody>
-      </p:sp>
-      <p:sp>
-        <p:nvSpPr>
-          <p:cNvPr id="15" name="Text 13"/>
-          <p:cNvSpPr/>
-          <p:nvPr/>
-        </p:nvSpPr>
-        <p:spPr>
-          <a:xfrm>
-            <a:off x="1234440" y="2066544"/>
-            <a:ext cx="2880360" cy="512064"/>
-          </a:xfrm>
-          <a:prstGeom prst="rect">
-            <a:avLst/>
-          </a:prstGeom>
-          <a:noFill/>
-          <a:ln/>
-        </p:spPr>
-        <p:txBody>
-          <a:bodyPr wrap="square" rtlCol="0" anchor="ctr"/>
-          <a:lstStyle/>
-          <a:p>
-            <a:pPr marL="0" indent="0">
-              <a:buNone/>
-            </a:pPr>
-            <a:r>
-              <a:rPr lang="en-US" sz="1300" b="1" dirty="0">
-                <a:solidFill>
-                  <a:srgbClr val="1E293B"/>
-                </a:solidFill>
-                <a:latin typeface="Calibri" pitchFamily="34" charset="0"/>
-                <a:ea typeface="Calibri" pitchFamily="34" charset="-122"/>
-                <a:cs typeface="Calibri" pitchFamily="34" charset="-120"/>
-              </a:rPr>
-              <a:t>Tokens &amp; context window</a:t>
-            </a:r>
-            <a:endParaRPr lang="en-US" sz="1300" dirty="0"/>
-          </a:p>
-        </p:txBody>
-      </p:sp>
-      <p:sp>
-        <p:nvSpPr>
-          <p:cNvPr id="16" name="Text 14"/>
-          <p:cNvSpPr/>
-          <p:nvPr/>
-        </p:nvSpPr>
-        <p:spPr>
-          <a:xfrm>
-            <a:off x="4206240" y="2066544"/>
-            <a:ext cx="4251960" cy="512064"/>
-          </a:xfrm>
-          <a:prstGeom prst="rect">
-            <a:avLst/>
-          </a:prstGeom>
-          <a:noFill/>
-          <a:ln/>
-        </p:spPr>
-        <p:txBody>
-          <a:bodyPr wrap="square" rtlCol="0" anchor="ctr"/>
-          <a:lstStyle/>
-          <a:p>
-            <a:pPr marL="0" indent="0">
-              <a:lnSpc>
-                <a:spcPct val="100000"/>
-              </a:lnSpc>
-              <a:buNone/>
-            </a:pPr>
-            <a:r>
-              <a:rPr lang="en-US" sz="1100" dirty="0">
-                <a:solidFill>
-                  <a:srgbClr val="64748B"/>
-                </a:solidFill>
-                <a:latin typeface="Calibri" pitchFamily="34" charset="0"/>
-                <a:ea typeface="Calibri" pitchFamily="34" charset="-122"/>
-                <a:cs typeface="Calibri" pitchFamily="34" charset="-120"/>
-              </a:rPr>
-              <a:t>The word-pieces a model reads, and how many it takes in at once — the hub’s embedder handles about 8K.</a:t>
-            </a:r>
-            <a:endParaRPr lang="en-US" sz="1100" dirty="0"/>
-          </a:p>
-        </p:txBody>
-      </p:sp>
-      <p:sp>
-        <p:nvSpPr>
-          <p:cNvPr id="17" name="Shape 15"/>
-          <p:cNvSpPr/>
-          <p:nvPr/>
-        </p:nvSpPr>
-        <p:spPr>
-          <a:xfrm>
-            <a:off x="502920" y="2724912"/>
-            <a:ext cx="8138160" cy="548640"/>
-          </a:xfrm>
-          <a:prstGeom prst="roundRect">
-            <a:avLst>
-              <a:gd name="adj" fmla="val 11667"/>
-            </a:avLst>
-          </a:prstGeom>
-          <a:solidFill>
-            <a:srgbClr val="FFFFFF"/>
-          </a:solidFill>
-          <a:ln w="9525">
-            <a:solidFill>
-              <a:srgbClr val="E2E8F0"/>
-            </a:solidFill>
-            <a:prstDash val="solid"/>
-          </a:ln>
-          <a:effectLst>
-            <a:outerShdw blurRad="76200" dist="38100" dir="5400000" algn="bl" rotWithShape="0">
-              <a:srgbClr val="000000">
-                <a:alpha val="10000"/>
-              </a:srgbClr>
-            </a:outerShdw>
-          </a:effectLst>
-        </p:spPr>
-        <p:txBody>
-          <a:bodyPr/>
-          <a:lstStyle/>
-          <a:p>
-            <a:endParaRPr lang="en-US"/>
-          </a:p>
-        </p:txBody>
-      </p:sp>
-      <p:sp>
-        <p:nvSpPr>
-          <p:cNvPr id="18" name="Shape 16"/>
-          <p:cNvSpPr/>
-          <p:nvPr/>
-        </p:nvSpPr>
-        <p:spPr>
-          <a:xfrm>
-            <a:off x="502920" y="2724912"/>
-            <a:ext cx="64008" cy="548640"/>
-          </a:xfrm>
-          <a:prstGeom prst="roundRect">
-            <a:avLst>
-              <a:gd name="adj" fmla="val 42857"/>
-            </a:avLst>
-          </a:prstGeom>
-          <a:solidFill>
-            <a:srgbClr val="7C3AED"/>
-          </a:solidFill>
-          <a:ln/>
-        </p:spPr>
-        <p:txBody>
-          <a:bodyPr/>
-          <a:lstStyle/>
-          <a:p>
-            <a:endParaRPr lang="en-US"/>
-          </a:p>
-        </p:txBody>
-      </p:sp>
-      <p:sp>
-        <p:nvSpPr>
-          <p:cNvPr id="19" name="Shape 17"/>
-          <p:cNvSpPr/>
-          <p:nvPr/>
-        </p:nvSpPr>
-        <p:spPr>
-          <a:xfrm>
-            <a:off x="731520" y="2807208"/>
-            <a:ext cx="384048" cy="384048"/>
-          </a:xfrm>
-          <a:prstGeom prst="roundRect">
-            <a:avLst>
-              <a:gd name="adj" fmla="val 16667"/>
-            </a:avLst>
-          </a:prstGeom>
-          <a:solidFill>
-            <a:srgbClr val="7C3AED"/>
-          </a:solidFill>
-          <a:ln/>
-        </p:spPr>
-        <p:txBody>
-          <a:bodyPr/>
-          <a:lstStyle/>
-          <a:p>
-            <a:endParaRPr lang="en-US"/>
-          </a:p>
-        </p:txBody>
-      </p:sp>
-      <p:sp>
-        <p:nvSpPr>
-          <p:cNvPr id="20" name="Text 18"/>
-          <p:cNvSpPr/>
-          <p:nvPr/>
-        </p:nvSpPr>
-        <p:spPr>
-          <a:xfrm>
-            <a:off x="731520" y="2807208"/>
-            <a:ext cx="384048" cy="384048"/>
-          </a:xfrm>
-          <a:prstGeom prst="rect">
-            <a:avLst/>
-          </a:prstGeom>
-          <a:noFill/>
-          <a:ln/>
-        </p:spPr>
-        <p:txBody>
-          <a:bodyPr wrap="square" rtlCol="0" anchor="ctr"/>
-          <a:lstStyle/>
-          <a:p>
-            <a:pPr marL="0" indent="0" algn="ctr">
-              <a:buNone/>
-            </a:pPr>
-            <a:r>
-              <a:rPr lang="en-US" sz="1800" b="1" dirty="0">
-                <a:solidFill>
-                  <a:srgbClr val="FFFFFF"/>
-                </a:solidFill>
-                <a:latin typeface="Calibri" pitchFamily="34" charset="0"/>
-                <a:ea typeface="Calibri" pitchFamily="34" charset="-122"/>
-                <a:cs typeface="Calibri" pitchFamily="34" charset="-120"/>
-              </a:rPr>
-              <a:t>★</a:t>
-            </a:r>
-            <a:endParaRPr lang="en-US" sz="1800" dirty="0"/>
-          </a:p>
-        </p:txBody>
-      </p:sp>
-      <p:sp>
-        <p:nvSpPr>
-          <p:cNvPr id="21" name="Text 19"/>
-          <p:cNvSpPr/>
-          <p:nvPr/>
-        </p:nvSpPr>
-        <p:spPr>
-          <a:xfrm>
-            <a:off x="1234440" y="2743200"/>
-            <a:ext cx="2880360" cy="512064"/>
-          </a:xfrm>
-          <a:prstGeom prst="rect">
-            <a:avLst/>
-          </a:prstGeom>
-          <a:noFill/>
-          <a:ln/>
-        </p:spPr>
-        <p:txBody>
-          <a:bodyPr wrap="square" rtlCol="0" anchor="ctr"/>
-          <a:lstStyle/>
-          <a:p>
-            <a:pPr marL="0" indent="0">
-              <a:buNone/>
-            </a:pPr>
-            <a:r>
-              <a:rPr lang="en-US" sz="1300" b="1" dirty="0">
-                <a:solidFill>
-                  <a:srgbClr val="1E293B"/>
-                </a:solidFill>
-                <a:latin typeface="Calibri" pitchFamily="34" charset="0"/>
-                <a:ea typeface="Calibri" pitchFamily="34" charset="-122"/>
-                <a:cs typeface="Calibri" pitchFamily="34" charset="-120"/>
-              </a:rPr>
-              <a:t>Vector store</a:t>
-            </a:r>
-            <a:endParaRPr lang="en-US" sz="1300" dirty="0"/>
-          </a:p>
-        </p:txBody>
-      </p:sp>
-      <p:sp>
-        <p:nvSpPr>
-          <p:cNvPr id="22" name="Text 20"/>
-          <p:cNvSpPr/>
-          <p:nvPr/>
-        </p:nvSpPr>
-        <p:spPr>
-          <a:xfrm>
-            <a:off x="4206240" y="2743200"/>
-            <a:ext cx="4251960" cy="512064"/>
-          </a:xfrm>
-          <a:prstGeom prst="rect">
-            <a:avLst/>
-          </a:prstGeom>
-          <a:noFill/>
-          <a:ln/>
-        </p:spPr>
-        <p:txBody>
-          <a:bodyPr wrap="square" rtlCol="0" anchor="ctr"/>
-          <a:lstStyle/>
-          <a:p>
-            <a:pPr marL="0" indent="0">
-              <a:lnSpc>
-                <a:spcPct val="100000"/>
-              </a:lnSpc>
-              <a:buNone/>
-            </a:pPr>
-            <a:r>
-              <a:rPr lang="en-US" sz="1100" dirty="0">
-                <a:solidFill>
-                  <a:srgbClr val="64748B"/>
-                </a:solidFill>
-                <a:latin typeface="Calibri" pitchFamily="34" charset="0"/>
-                <a:ea typeface="Calibri" pitchFamily="34" charset="-122"/>
-                <a:cs typeface="Calibri" pitchFamily="34" charset="-120"/>
-              </a:rPr>
-              <a:t>A database that holds embeddings and finds the nearest ones to a query fast. ChromaDB plays this role here.</a:t>
-            </a:r>
-            <a:endParaRPr lang="en-US" sz="1100" dirty="0"/>
-          </a:p>
-        </p:txBody>
-      </p:sp>
-      <p:sp>
-        <p:nvSpPr>
-          <p:cNvPr id="23" name="Shape 21"/>
-          <p:cNvSpPr/>
-          <p:nvPr/>
-        </p:nvSpPr>
-        <p:spPr>
-          <a:xfrm>
-            <a:off x="502920" y="3401568"/>
-            <a:ext cx="8138160" cy="548640"/>
-          </a:xfrm>
-          <a:prstGeom prst="roundRect">
-            <a:avLst>
-              <a:gd name="adj" fmla="val 11667"/>
-            </a:avLst>
-          </a:prstGeom>
-          <a:solidFill>
-            <a:srgbClr val="FFFFFF"/>
-          </a:solidFill>
-          <a:ln w="9525">
-            <a:solidFill>
-              <a:srgbClr val="E2E8F0"/>
-            </a:solidFill>
-            <a:prstDash val="solid"/>
-          </a:ln>
-          <a:effectLst>
-            <a:outerShdw blurRad="76200" dist="38100" dir="5400000" algn="bl" rotWithShape="0">
-              <a:srgbClr val="000000">
-                <a:alpha val="10000"/>
-              </a:srgbClr>
-            </a:outerShdw>
-          </a:effectLst>
-        </p:spPr>
-        <p:txBody>
-          <a:bodyPr/>
-          <a:lstStyle/>
-          <a:p>
-            <a:endParaRPr lang="en-US"/>
-          </a:p>
-        </p:txBody>
-      </p:sp>
-      <p:sp>
-        <p:nvSpPr>
-          <p:cNvPr id="24" name="Shape 22"/>
-          <p:cNvSpPr/>
-          <p:nvPr/>
-        </p:nvSpPr>
-        <p:spPr>
-          <a:xfrm>
-            <a:off x="502920" y="3401568"/>
-            <a:ext cx="64008" cy="548640"/>
-          </a:xfrm>
-          <a:prstGeom prst="roundRect">
-            <a:avLst>
-              <a:gd name="adj" fmla="val 42857"/>
-            </a:avLst>
-          </a:prstGeom>
-          <a:solidFill>
-            <a:srgbClr val="2563EB"/>
-          </a:solidFill>
-          <a:ln/>
-        </p:spPr>
-        <p:txBody>
-          <a:bodyPr/>
-          <a:lstStyle/>
-          <a:p>
-            <a:endParaRPr lang="en-US"/>
-          </a:p>
-        </p:txBody>
-      </p:sp>
-      <p:sp>
-        <p:nvSpPr>
-          <p:cNvPr id="25" name="Shape 23"/>
-          <p:cNvSpPr/>
-          <p:nvPr/>
-        </p:nvSpPr>
-        <p:spPr>
-          <a:xfrm>
-            <a:off x="731520" y="3483864"/>
-            <a:ext cx="384048" cy="384048"/>
-          </a:xfrm>
-          <a:prstGeom prst="roundRect">
-            <a:avLst>
-              <a:gd name="adj" fmla="val 16667"/>
-            </a:avLst>
-          </a:prstGeom>
-          <a:solidFill>
-            <a:srgbClr val="2563EB"/>
-          </a:solidFill>
-          <a:ln/>
-        </p:spPr>
-        <p:txBody>
-          <a:bodyPr/>
-          <a:lstStyle/>
-          <a:p>
-            <a:endParaRPr lang="en-US"/>
-          </a:p>
-        </p:txBody>
-      </p:sp>
-      <p:sp>
-        <p:nvSpPr>
-          <p:cNvPr id="26" name="Text 24"/>
-          <p:cNvSpPr/>
-          <p:nvPr/>
-        </p:nvSpPr>
-        <p:spPr>
-          <a:xfrm>
-            <a:off x="731520" y="3483864"/>
-            <a:ext cx="384048" cy="384048"/>
-          </a:xfrm>
-          <a:prstGeom prst="rect">
-            <a:avLst/>
-          </a:prstGeom>
-          <a:noFill/>
-          <a:ln/>
-        </p:spPr>
-        <p:txBody>
-          <a:bodyPr wrap="square" rtlCol="0" anchor="ctr"/>
-          <a:lstStyle/>
-          <a:p>
-            <a:pPr marL="0" indent="0" algn="ctr">
-              <a:buNone/>
-            </a:pPr>
-            <a:r>
-              <a:rPr lang="en-US" sz="1800" b="1" dirty="0">
-                <a:solidFill>
-                  <a:srgbClr val="FFFFFF"/>
-                </a:solidFill>
-                <a:latin typeface="Calibri" pitchFamily="34" charset="0"/>
-                <a:ea typeface="Calibri" pitchFamily="34" charset="-122"/>
-                <a:cs typeface="Calibri" pitchFamily="34" charset="-120"/>
-              </a:rPr>
-              <a:t>◆</a:t>
-            </a:r>
-            <a:endParaRPr lang="en-US" sz="1800" dirty="0"/>
-          </a:p>
-        </p:txBody>
-      </p:sp>
-      <p:sp>
-        <p:nvSpPr>
-          <p:cNvPr id="27" name="Text 25"/>
-          <p:cNvSpPr/>
-          <p:nvPr/>
-        </p:nvSpPr>
-        <p:spPr>
-          <a:xfrm>
-            <a:off x="1234440" y="3419856"/>
-            <a:ext cx="2880360" cy="512064"/>
-          </a:xfrm>
-          <a:prstGeom prst="rect">
-            <a:avLst/>
-          </a:prstGeom>
-          <a:noFill/>
-          <a:ln/>
-        </p:spPr>
-        <p:txBody>
-          <a:bodyPr wrap="square" rtlCol="0" anchor="ctr"/>
-          <a:lstStyle/>
-          <a:p>
-            <a:pPr marL="0" indent="0">
-              <a:buNone/>
-            </a:pPr>
-            <a:r>
-              <a:rPr lang="en-US" sz="1300" b="1" dirty="0">
-                <a:solidFill>
-                  <a:srgbClr val="1E293B"/>
-                </a:solidFill>
-                <a:latin typeface="Calibri" pitchFamily="34" charset="0"/>
-                <a:ea typeface="Calibri" pitchFamily="34" charset="-122"/>
-                <a:cs typeface="Calibri" pitchFamily="34" charset="-120"/>
-              </a:rPr>
-              <a:t>Semantic similarity</a:t>
-            </a:r>
-            <a:endParaRPr lang="en-US" sz="1300" dirty="0"/>
-          </a:p>
-        </p:txBody>
-      </p:sp>
-      <p:sp>
-        <p:nvSpPr>
-          <p:cNvPr id="28" name="Text 26"/>
-          <p:cNvSpPr/>
-          <p:nvPr/>
-        </p:nvSpPr>
-        <p:spPr>
-          <a:xfrm>
-            <a:off x="4206240" y="3419856"/>
-            <a:ext cx="4251960" cy="512064"/>
-          </a:xfrm>
-          <a:prstGeom prst="rect">
-            <a:avLst/>
-          </a:prstGeom>
-          <a:noFill/>
-          <a:ln/>
-        </p:spPr>
-        <p:txBody>
-          <a:bodyPr wrap="square" rtlCol="0" anchor="ctr"/>
-          <a:lstStyle/>
-          <a:p>
-            <a:pPr marL="0" indent="0">
-              <a:lnSpc>
-                <a:spcPct val="100000"/>
-              </a:lnSpc>
-              <a:buNone/>
-            </a:pPr>
-            <a:r>
-              <a:rPr lang="en-US" sz="1100" dirty="0">
-                <a:solidFill>
-                  <a:srgbClr val="64748B"/>
-                </a:solidFill>
-                <a:latin typeface="Calibri" pitchFamily="34" charset="0"/>
-                <a:ea typeface="Calibri" pitchFamily="34" charset="-122"/>
-                <a:cs typeface="Calibri" pitchFamily="34" charset="-120"/>
-              </a:rPr>
-              <a:t>Closeness in meaning rather than wording — so “DAX” and “calculation language” can match with no shared words.</a:t>
-            </a:r>
-            <a:endParaRPr lang="en-US" sz="1100" dirty="0"/>
-          </a:p>
-        </p:txBody>
-      </p:sp>
-      <p:sp>
-        <p:nvSpPr>
-          <p:cNvPr id="29" name="Shape 27"/>
-          <p:cNvSpPr/>
-          <p:nvPr/>
-        </p:nvSpPr>
-        <p:spPr>
-          <a:xfrm>
-            <a:off x="502920" y="4078224"/>
-            <a:ext cx="8138160" cy="548640"/>
-          </a:xfrm>
-          <a:prstGeom prst="roundRect">
-            <a:avLst>
-              <a:gd name="adj" fmla="val 11667"/>
-            </a:avLst>
-          </a:prstGeom>
-          <a:solidFill>
-            <a:srgbClr val="FFFFFF"/>
-          </a:solidFill>
-          <a:ln w="9525">
-            <a:solidFill>
-              <a:srgbClr val="E2E8F0"/>
-            </a:solidFill>
-            <a:prstDash val="solid"/>
-          </a:ln>
-          <a:effectLst>
-            <a:outerShdw blurRad="76200" dist="38100" dir="5400000" algn="bl" rotWithShape="0">
-              <a:srgbClr val="000000">
-                <a:alpha val="10000"/>
-              </a:srgbClr>
-            </a:outerShdw>
-          </a:effectLst>
-        </p:spPr>
-        <p:txBody>
-          <a:bodyPr/>
-          <a:lstStyle/>
-          <a:p>
-            <a:endParaRPr lang="en-US"/>
-          </a:p>
-        </p:txBody>
-      </p:sp>
-      <p:sp>
-        <p:nvSpPr>
-          <p:cNvPr id="30" name="Shape 28"/>
-          <p:cNvSpPr/>
-          <p:nvPr/>
-        </p:nvSpPr>
-        <p:spPr>
-          <a:xfrm>
-            <a:off x="502920" y="4078224"/>
-            <a:ext cx="64008" cy="548640"/>
-          </a:xfrm>
-          <a:prstGeom prst="roundRect">
-            <a:avLst>
-              <a:gd name="adj" fmla="val 42857"/>
-            </a:avLst>
-          </a:prstGeom>
-          <a:solidFill>
-            <a:srgbClr val="0D9488"/>
-          </a:solidFill>
-          <a:ln/>
-        </p:spPr>
-        <p:txBody>
-          <a:bodyPr/>
-          <a:lstStyle/>
-          <a:p>
-            <a:endParaRPr lang="en-US"/>
-          </a:p>
-        </p:txBody>
-      </p:sp>
-      <p:sp>
-        <p:nvSpPr>
-          <p:cNvPr id="31" name="Shape 29"/>
-          <p:cNvSpPr/>
-          <p:nvPr/>
-        </p:nvSpPr>
-        <p:spPr>
-          <a:xfrm>
-            <a:off x="731520" y="4160520"/>
-            <a:ext cx="384048" cy="384048"/>
-          </a:xfrm>
-          <a:prstGeom prst="roundRect">
-            <a:avLst>
-              <a:gd name="adj" fmla="val 16667"/>
-            </a:avLst>
-          </a:prstGeom>
-          <a:solidFill>
-            <a:srgbClr val="0D9488"/>
-          </a:solidFill>
-          <a:ln/>
-        </p:spPr>
-        <p:txBody>
-          <a:bodyPr/>
-          <a:lstStyle/>
-          <a:p>
-            <a:endParaRPr lang="en-US"/>
-          </a:p>
-        </p:txBody>
-      </p:sp>
-      <p:sp>
-        <p:nvSpPr>
-          <p:cNvPr id="32" name="Text 30"/>
-          <p:cNvSpPr/>
-          <p:nvPr/>
-        </p:nvSpPr>
-        <p:spPr>
-          <a:xfrm>
-            <a:off x="731520" y="4160520"/>
-            <a:ext cx="384048" cy="384048"/>
-          </a:xfrm>
-          <a:prstGeom prst="rect">
-            <a:avLst/>
-          </a:prstGeom>
-          <a:noFill/>
-          <a:ln/>
-        </p:spPr>
-        <p:txBody>
-          <a:bodyPr wrap="square" rtlCol="0" anchor="ctr"/>
-          <a:lstStyle/>
-          <a:p>
-            <a:pPr marL="0" indent="0" algn="ctr">
-              <a:buNone/>
-            </a:pPr>
-            <a:r>
-              <a:rPr lang="en-US" sz="1800" b="1" dirty="0">
-                <a:solidFill>
-                  <a:srgbClr val="FFFFFF"/>
-                </a:solidFill>
-                <a:latin typeface="Calibri" pitchFamily="34" charset="0"/>
-                <a:ea typeface="Calibri" pitchFamily="34" charset="-122"/>
-                <a:cs typeface="Calibri" pitchFamily="34" charset="-120"/>
-              </a:rPr>
-              <a:t>?</a:t>
-            </a:r>
-            <a:endParaRPr lang="en-US" sz="1800" dirty="0"/>
-          </a:p>
-        </p:txBody>
-      </p:sp>
-      <p:sp>
-        <p:nvSpPr>
-          <p:cNvPr id="33" name="Text 31"/>
-          <p:cNvSpPr/>
-          <p:nvPr/>
-        </p:nvSpPr>
-        <p:spPr>
-          <a:xfrm>
-            <a:off x="1234440" y="4096512"/>
-            <a:ext cx="2880360" cy="512064"/>
-          </a:xfrm>
-          <a:prstGeom prst="rect">
-            <a:avLst/>
-          </a:prstGeom>
-          <a:noFill/>
-          <a:ln/>
-        </p:spPr>
-        <p:txBody>
-          <a:bodyPr wrap="square" rtlCol="0" anchor="ctr"/>
-          <a:lstStyle/>
-          <a:p>
-            <a:pPr marL="0" indent="0">
-              <a:buNone/>
-            </a:pPr>
-            <a:r>
-              <a:rPr lang="en-US" sz="1300" b="1" dirty="0">
-                <a:solidFill>
-                  <a:srgbClr val="1E293B"/>
-                </a:solidFill>
-                <a:latin typeface="Calibri" pitchFamily="34" charset="0"/>
-                <a:ea typeface="Calibri" pitchFamily="34" charset="-122"/>
-                <a:cs typeface="Calibri" pitchFamily="34" charset="-120"/>
-              </a:rPr>
-              <a:t>RAG</a:t>
-            </a:r>
-            <a:endParaRPr lang="en-US" sz="1300" dirty="0"/>
-          </a:p>
-        </p:txBody>
-      </p:sp>
-      <p:sp>
-        <p:nvSpPr>
-          <p:cNvPr id="34" name="Text 32"/>
-          <p:cNvSpPr/>
-          <p:nvPr/>
-        </p:nvSpPr>
-        <p:spPr>
-          <a:xfrm>
-            <a:off x="4206240" y="4096512"/>
-            <a:ext cx="4251960" cy="512064"/>
-          </a:xfrm>
-          <a:prstGeom prst="rect">
-            <a:avLst/>
-          </a:prstGeom>
-          <a:noFill/>
-          <a:ln/>
-        </p:spPr>
-        <p:txBody>
-          <a:bodyPr wrap="square" rtlCol="0" anchor="ctr"/>
-          <a:lstStyle/>
-          <a:p>
-            <a:pPr marL="0" indent="0">
-              <a:lnSpc>
-                <a:spcPct val="100000"/>
-              </a:lnSpc>
-              <a:buNone/>
-            </a:pPr>
-            <a:r>
-              <a:rPr lang="en-US" sz="1100" dirty="0">
-                <a:solidFill>
-                  <a:srgbClr val="64748B"/>
-                </a:solidFill>
-                <a:latin typeface="Calibri" pitchFamily="34" charset="0"/>
-                <a:ea typeface="Calibri" pitchFamily="34" charset="-122"/>
-                <a:cs typeface="Calibri" pitchFamily="34" charset="-120"/>
-              </a:rPr>
-              <a:t>Retrieval-Augmented Generation: fetch relevant text first, then answer from it — grounding the answer in sources.</a:t>
-            </a:r>
-            <a:endParaRPr lang="en-US" sz="1100" dirty="0"/>
-          </a:p>
-        </p:txBody>
-      </p:sp>
-      <p:sp>
-        <p:nvSpPr>
-          <p:cNvPr id="35" name="Text 33"/>
-          <p:cNvSpPr/>
-          <p:nvPr/>
-        </p:nvSpPr>
-        <p:spPr>
-          <a:xfrm>
-            <a:off x="7982520" y="4828032"/>
-            <a:ext cx="750000" cy="256032"/>
-          </a:xfrm>
-          <a:prstGeom prst="rect">
-            <a:avLst/>
-          </a:prstGeom>
-          <a:noFill/>
-          <a:ln/>
-        </p:spPr>
-        <p:txBody>
-          <a:bodyPr wrap="square" rtlCol="0" anchor="ctr"/>
-          <a:lstStyle/>
-          <a:p>
-            <a:pPr marL="0" indent="0" algn="r">
-              <a:buNone/>
-            </a:pPr>
-            <a:r>
-              <a:rPr lang="en-US" sz="900" dirty="0">
-                <a:solidFill>
-                  <a:srgbClr val="94A3B8"/>
-                </a:solidFill>
-                <a:latin typeface="Calibri" pitchFamily="34" charset="0"/>
-                <a:ea typeface="Calibri" pitchFamily="34" charset="-122"/>
-                <a:cs typeface="Calibri" pitchFamily="34" charset="-120"/>
-              </a:rPr>
-              <a:t>Glossary</a:t>
-            </a:r>
-            <a:endParaRPr lang="en-US" sz="900" dirty="0"/>
           </a:p>
         </p:txBody>
       </p:sp>
@@ -15417,7 +14911,7 @@
                 <a:ea typeface="Trebuchet MS" pitchFamily="34" charset="-122"/>
                 <a:cs typeface="Trebuchet MS" pitchFamily="34" charset="-120"/>
               </a:rPr>
-              <a:t>Glossary — graphs, models &amp; glue</a:t>
+              <a:t>Glossary — the retrieval side</a:t>
             </a:r>
             <a:endParaRPr lang="en-US" sz="2700" dirty="0"/>
           </a:p>
@@ -15456,7 +14950,7 @@
                 <a:ea typeface="Calibri" pitchFamily="34" charset="-122"/>
                 <a:cs typeface="Calibri" pitchFamily="34" charset="-120"/>
               </a:rPr>
-              <a:t>How the pieces connect — still nothing Power BI-specific</a:t>
+              <a:t>The ideas behind the rabbit holes — none of it Fabric-specific</a:t>
             </a:r>
             <a:endParaRPr lang="en-US" sz="1300" dirty="0"/>
           </a:p>
@@ -15633,7 +15127,7 @@
                 <a:ea typeface="Calibri" pitchFamily="34" charset="-122"/>
                 <a:cs typeface="Calibri" pitchFamily="34" charset="-120"/>
               </a:rPr>
-              <a:t>Knowledge graph</a:t>
+              <a:t>Embedding</a:t>
             </a:r>
             <a:endParaRPr lang="en-US" sz="1300" dirty="0"/>
           </a:p>
@@ -15675,7 +15169,7 @@
                 <a:ea typeface="Calibri" pitchFamily="34" charset="-122"/>
                 <a:cs typeface="Calibri" pitchFamily="34" charset="-120"/>
               </a:rPr>
-              <a:t>A network of facts: things connected by relationships, capturing how concepts link, not just what one article says.</a:t>
+              <a:t>Text turned into a list of numbers that captures its meaning, so similar ideas sit close together in space.</a:t>
             </a:r>
             <a:endParaRPr lang="en-US" sz="1100" dirty="0"/>
           </a:p>
@@ -15852,7 +15346,7 @@
                 <a:ea typeface="Calibri" pitchFamily="34" charset="-122"/>
                 <a:cs typeface="Calibri" pitchFamily="34" charset="-120"/>
               </a:rPr>
-              <a:t>Entity</a:t>
+              <a:t>Tokens &amp; context window</a:t>
             </a:r>
             <a:endParaRPr lang="en-US" sz="1300" dirty="0"/>
           </a:p>
@@ -15894,7 +15388,7 @@
                 <a:ea typeface="Calibri" pitchFamily="34" charset="-122"/>
                 <a:cs typeface="Calibri" pitchFamily="34" charset="-120"/>
               </a:rPr>
-              <a:t>A named thing pulled from the text — a feature, person, product or concept. These are the nodes of the graph.</a:t>
+              <a:t>The word-pieces a model reads, and how many it takes in at once — the hub’s embedder handles about 8K.</a:t>
             </a:r>
             <a:endParaRPr lang="en-US" sz="1100" dirty="0"/>
           </a:p>
@@ -16071,7 +15565,7 @@
                 <a:ea typeface="Calibri" pitchFamily="34" charset="-122"/>
                 <a:cs typeface="Calibri" pitchFamily="34" charset="-120"/>
               </a:rPr>
-              <a:t>Relationship (edge)</a:t>
+              <a:t>Vector store</a:t>
             </a:r>
             <a:endParaRPr lang="en-US" sz="1300" dirty="0"/>
           </a:p>
@@ -16113,7 +15607,7 @@
                 <a:ea typeface="Calibri" pitchFamily="34" charset="-122"/>
                 <a:cs typeface="Calibri" pitchFamily="34" charset="-120"/>
               </a:rPr>
-              <a:t>A connection between two entities — “X depends on Y,” “A is an alternative to B.” The lines of the graph.</a:t>
+              <a:t>A database that holds embeddings and finds the nearest ones to a query fast. ChromaDB plays this role here.</a:t>
             </a:r>
             <a:endParaRPr lang="en-US" sz="1100" dirty="0"/>
           </a:p>
@@ -16290,7 +15784,7 @@
                 <a:ea typeface="Calibri" pitchFamily="34" charset="-122"/>
                 <a:cs typeface="Calibri" pitchFamily="34" charset="-120"/>
               </a:rPr>
-              <a:t>LLM</a:t>
+              <a:t>Semantic similarity</a:t>
             </a:r>
             <a:endParaRPr lang="en-US" sz="1300" dirty="0"/>
           </a:p>
@@ -16332,7 +15826,7 @@
                 <a:ea typeface="Calibri" pitchFamily="34" charset="-122"/>
                 <a:cs typeface="Calibri" pitchFamily="34" charset="-120"/>
               </a:rPr>
-              <a:t>Large Language Model — reads and writes language; here it extracts entities and reasons over what’s retrieved.</a:t>
+              <a:t>Closeness in meaning rather than wording — so “DAX” and “calculation language” can match with no shared words.</a:t>
             </a:r>
             <a:endParaRPr lang="en-US" sz="1100" dirty="0"/>
           </a:p>
@@ -16509,7 +16003,7 @@
                 <a:ea typeface="Calibri" pitchFamily="34" charset="-122"/>
                 <a:cs typeface="Calibri" pitchFamily="34" charset="-120"/>
               </a:rPr>
-              <a:t>MCP</a:t>
+              <a:t>RAG</a:t>
             </a:r>
             <a:endParaRPr lang="en-US" sz="1300" dirty="0"/>
           </a:p>
@@ -16551,7 +16045,7 @@
                 <a:ea typeface="Calibri" pitchFamily="34" charset="-122"/>
                 <a:cs typeface="Calibri" pitchFamily="34" charset="-120"/>
               </a:rPr>
-              <a:t>Model Context Protocol — an open standard for a model to call external tools uniformly; the hub exposes retrieval as one.</a:t>
+              <a:t>Retrieval-Augmented Generation: fetch relevant text first, then answer from it — grounding the answer in sources.</a:t>
             </a:r>
             <a:endParaRPr lang="en-US" sz="1100" dirty="0"/>
           </a:p>
@@ -16605,6 +16099,1251 @@
 </file>
 
 <file path=ppt/slides/slide26.xml><?xml version="1.0" encoding="utf-8"?>
+<p:sld xmlns:a="http://schemas.openxmlformats.org/drawingml/2006/main" xmlns:r="http://schemas.openxmlformats.org/officeDocument/2006/relationships" xmlns:p="http://schemas.openxmlformats.org/presentationml/2006/main">
+  <p:cSld name="Slide 17">
+    <p:bg>
+      <p:bgPr>
+        <a:solidFill>
+          <a:srgbClr val="F8FAFC"/>
+        </a:solidFill>
+        <a:effectLst/>
+      </p:bgPr>
+    </p:bg>
+    <p:spTree>
+      <p:nvGrpSpPr>
+        <p:cNvPr id="1" name=""/>
+        <p:cNvGrpSpPr/>
+        <p:nvPr/>
+      </p:nvGrpSpPr>
+      <p:grpSpPr>
+        <a:xfrm>
+          <a:off x="0" y="0"/>
+          <a:ext cx="0" cy="0"/>
+          <a:chOff x="0" y="0"/>
+          <a:chExt cx="0" cy="0"/>
+        </a:xfrm>
+      </p:grpSpPr>
+      <p:sp>
+        <p:nvSpPr>
+          <p:cNvPr id="2" name="Text 0"/>
+          <p:cNvSpPr/>
+          <p:nvPr/>
+        </p:nvSpPr>
+        <p:spPr>
+          <a:xfrm>
+            <a:off x="502920" y="274320"/>
+            <a:ext cx="8138160" cy="548640"/>
+          </a:xfrm>
+          <a:prstGeom prst="rect">
+            <a:avLst/>
+          </a:prstGeom>
+          <a:noFill/>
+          <a:ln/>
+        </p:spPr>
+        <p:txBody>
+          <a:bodyPr wrap="square" rtlCol="0" anchor="ctr"/>
+          <a:lstStyle/>
+          <a:p>
+            <a:pPr marL="0" indent="0" algn="l">
+              <a:buNone/>
+            </a:pPr>
+            <a:r>
+              <a:rPr lang="en-US" sz="2700" b="1" dirty="0">
+                <a:solidFill>
+                  <a:srgbClr val="1E293B"/>
+                </a:solidFill>
+                <a:latin typeface="Trebuchet MS" pitchFamily="34" charset="0"/>
+                <a:ea typeface="Trebuchet MS" pitchFamily="34" charset="-122"/>
+                <a:cs typeface="Trebuchet MS" pitchFamily="34" charset="-120"/>
+              </a:rPr>
+              <a:t>Glossary — graphs, models &amp; glue</a:t>
+            </a:r>
+            <a:endParaRPr lang="en-US" sz="2700" dirty="0"/>
+          </a:p>
+        </p:txBody>
+      </p:sp>
+      <p:sp>
+        <p:nvSpPr>
+          <p:cNvPr id="3" name="Text 1"/>
+          <p:cNvSpPr/>
+          <p:nvPr/>
+        </p:nvSpPr>
+        <p:spPr>
+          <a:xfrm>
+            <a:off x="502920" y="841248"/>
+            <a:ext cx="8138160" cy="310896"/>
+          </a:xfrm>
+          <a:prstGeom prst="rect">
+            <a:avLst/>
+          </a:prstGeom>
+          <a:noFill/>
+          <a:ln/>
+        </p:spPr>
+        <p:txBody>
+          <a:bodyPr wrap="square" rtlCol="0" anchor="ctr"/>
+          <a:lstStyle/>
+          <a:p>
+            <a:pPr marL="0" indent="0" algn="l">
+              <a:buNone/>
+            </a:pPr>
+            <a:r>
+              <a:rPr lang="en-US" sz="1300" dirty="0">
+                <a:solidFill>
+                  <a:srgbClr val="64748B"/>
+                </a:solidFill>
+                <a:latin typeface="Calibri" pitchFamily="34" charset="0"/>
+                <a:ea typeface="Calibri" pitchFamily="34" charset="-122"/>
+                <a:cs typeface="Calibri" pitchFamily="34" charset="-120"/>
+              </a:rPr>
+              <a:t>How the pieces connect — still nothing Power BI-specific</a:t>
+            </a:r>
+            <a:endParaRPr lang="en-US" sz="1300" dirty="0"/>
+          </a:p>
+        </p:txBody>
+      </p:sp>
+      <p:sp>
+        <p:nvSpPr>
+          <p:cNvPr id="5" name="Shape 3"/>
+          <p:cNvSpPr/>
+          <p:nvPr/>
+        </p:nvSpPr>
+        <p:spPr>
+          <a:xfrm>
+            <a:off x="502920" y="1371600"/>
+            <a:ext cx="8138160" cy="548640"/>
+          </a:xfrm>
+          <a:prstGeom prst="roundRect">
+            <a:avLst>
+              <a:gd name="adj" fmla="val 11667"/>
+            </a:avLst>
+          </a:prstGeom>
+          <a:solidFill>
+            <a:srgbClr val="FFFFFF"/>
+          </a:solidFill>
+          <a:ln w="9525">
+            <a:solidFill>
+              <a:srgbClr val="E2E8F0"/>
+            </a:solidFill>
+            <a:prstDash val="solid"/>
+          </a:ln>
+          <a:effectLst>
+            <a:outerShdw blurRad="76200" dist="38100" dir="5400000" algn="bl" rotWithShape="0">
+              <a:srgbClr val="000000">
+                <a:alpha val="10000"/>
+              </a:srgbClr>
+            </a:outerShdw>
+          </a:effectLst>
+        </p:spPr>
+        <p:txBody>
+          <a:bodyPr/>
+          <a:lstStyle/>
+          <a:p>
+            <a:endParaRPr lang="en-US"/>
+          </a:p>
+        </p:txBody>
+      </p:sp>
+      <p:sp>
+        <p:nvSpPr>
+          <p:cNvPr id="6" name="Shape 4"/>
+          <p:cNvSpPr/>
+          <p:nvPr/>
+        </p:nvSpPr>
+        <p:spPr>
+          <a:xfrm>
+            <a:off x="502920" y="1371600"/>
+            <a:ext cx="64008" cy="548640"/>
+          </a:xfrm>
+          <a:prstGeom prst="roundRect">
+            <a:avLst>
+              <a:gd name="adj" fmla="val 42857"/>
+            </a:avLst>
+          </a:prstGeom>
+          <a:solidFill>
+            <a:srgbClr val="0D9488"/>
+          </a:solidFill>
+          <a:ln/>
+        </p:spPr>
+        <p:txBody>
+          <a:bodyPr/>
+          <a:lstStyle/>
+          <a:p>
+            <a:endParaRPr lang="en-US"/>
+          </a:p>
+        </p:txBody>
+      </p:sp>
+      <p:sp>
+        <p:nvSpPr>
+          <p:cNvPr id="7" name="Shape 5"/>
+          <p:cNvSpPr/>
+          <p:nvPr/>
+        </p:nvSpPr>
+        <p:spPr>
+          <a:xfrm>
+            <a:off x="731520" y="1453896"/>
+            <a:ext cx="384048" cy="384048"/>
+          </a:xfrm>
+          <a:prstGeom prst="roundRect">
+            <a:avLst>
+              <a:gd name="adj" fmla="val 16667"/>
+            </a:avLst>
+          </a:prstGeom>
+          <a:solidFill>
+            <a:srgbClr val="0D9488"/>
+          </a:solidFill>
+          <a:ln/>
+        </p:spPr>
+        <p:txBody>
+          <a:bodyPr/>
+          <a:lstStyle/>
+          <a:p>
+            <a:endParaRPr lang="en-US"/>
+          </a:p>
+        </p:txBody>
+      </p:sp>
+      <p:sp>
+        <p:nvSpPr>
+          <p:cNvPr id="8" name="Text 6"/>
+          <p:cNvSpPr/>
+          <p:nvPr/>
+        </p:nvSpPr>
+        <p:spPr>
+          <a:xfrm>
+            <a:off x="731520" y="1453896"/>
+            <a:ext cx="384048" cy="384048"/>
+          </a:xfrm>
+          <a:prstGeom prst="rect">
+            <a:avLst/>
+          </a:prstGeom>
+          <a:noFill/>
+          <a:ln/>
+        </p:spPr>
+        <p:txBody>
+          <a:bodyPr wrap="square" rtlCol="0" anchor="ctr"/>
+          <a:lstStyle/>
+          <a:p>
+            <a:pPr marL="0" indent="0" algn="ctr">
+              <a:buNone/>
+            </a:pPr>
+            <a:r>
+              <a:rPr lang="en-US" sz="1800" b="1" dirty="0">
+                <a:solidFill>
+                  <a:srgbClr val="FFFFFF"/>
+                </a:solidFill>
+                <a:latin typeface="Calibri" pitchFamily="34" charset="0"/>
+                <a:ea typeface="Calibri" pitchFamily="34" charset="-122"/>
+                <a:cs typeface="Calibri" pitchFamily="34" charset="-120"/>
+              </a:rPr>
+              <a:t>⇄</a:t>
+            </a:r>
+            <a:endParaRPr lang="en-US" sz="1800" dirty="0"/>
+          </a:p>
+        </p:txBody>
+      </p:sp>
+      <p:sp>
+        <p:nvSpPr>
+          <p:cNvPr id="9" name="Text 7"/>
+          <p:cNvSpPr/>
+          <p:nvPr/>
+        </p:nvSpPr>
+        <p:spPr>
+          <a:xfrm>
+            <a:off x="1234440" y="1389888"/>
+            <a:ext cx="2880360" cy="512064"/>
+          </a:xfrm>
+          <a:prstGeom prst="rect">
+            <a:avLst/>
+          </a:prstGeom>
+          <a:noFill/>
+          <a:ln/>
+        </p:spPr>
+        <p:txBody>
+          <a:bodyPr wrap="square" rtlCol="0" anchor="ctr"/>
+          <a:lstStyle/>
+          <a:p>
+            <a:pPr marL="0" indent="0">
+              <a:buNone/>
+            </a:pPr>
+            <a:r>
+              <a:rPr lang="en-US" sz="1300" b="1" dirty="0">
+                <a:solidFill>
+                  <a:srgbClr val="1E293B"/>
+                </a:solidFill>
+                <a:latin typeface="Calibri" pitchFamily="34" charset="0"/>
+                <a:ea typeface="Calibri" pitchFamily="34" charset="-122"/>
+                <a:cs typeface="Calibri" pitchFamily="34" charset="-120"/>
+              </a:rPr>
+              <a:t>Knowledge graph</a:t>
+            </a:r>
+            <a:endParaRPr lang="en-US" sz="1300" dirty="0"/>
+          </a:p>
+        </p:txBody>
+      </p:sp>
+      <p:sp>
+        <p:nvSpPr>
+          <p:cNvPr id="10" name="Text 8"/>
+          <p:cNvSpPr/>
+          <p:nvPr/>
+        </p:nvSpPr>
+        <p:spPr>
+          <a:xfrm>
+            <a:off x="4206240" y="1389888"/>
+            <a:ext cx="4251960" cy="512064"/>
+          </a:xfrm>
+          <a:prstGeom prst="rect">
+            <a:avLst/>
+          </a:prstGeom>
+          <a:noFill/>
+          <a:ln/>
+        </p:spPr>
+        <p:txBody>
+          <a:bodyPr wrap="square" rtlCol="0" anchor="ctr"/>
+          <a:lstStyle/>
+          <a:p>
+            <a:pPr marL="0" indent="0">
+              <a:lnSpc>
+                <a:spcPct val="100000"/>
+              </a:lnSpc>
+              <a:buNone/>
+            </a:pPr>
+            <a:r>
+              <a:rPr lang="en-US" sz="1100" dirty="0">
+                <a:solidFill>
+                  <a:srgbClr val="64748B"/>
+                </a:solidFill>
+                <a:latin typeface="Calibri" pitchFamily="34" charset="0"/>
+                <a:ea typeface="Calibri" pitchFamily="34" charset="-122"/>
+                <a:cs typeface="Calibri" pitchFamily="34" charset="-120"/>
+              </a:rPr>
+              <a:t>A network of facts: things connected by relationships, capturing how concepts link, not just what one article says.</a:t>
+            </a:r>
+            <a:endParaRPr lang="en-US" sz="1100" dirty="0"/>
+          </a:p>
+        </p:txBody>
+      </p:sp>
+      <p:sp>
+        <p:nvSpPr>
+          <p:cNvPr id="11" name="Shape 9"/>
+          <p:cNvSpPr/>
+          <p:nvPr/>
+        </p:nvSpPr>
+        <p:spPr>
+          <a:xfrm>
+            <a:off x="502920" y="2048256"/>
+            <a:ext cx="8138160" cy="548640"/>
+          </a:xfrm>
+          <a:prstGeom prst="roundRect">
+            <a:avLst>
+              <a:gd name="adj" fmla="val 11667"/>
+            </a:avLst>
+          </a:prstGeom>
+          <a:solidFill>
+            <a:srgbClr val="FFFFFF"/>
+          </a:solidFill>
+          <a:ln w="9525">
+            <a:solidFill>
+              <a:srgbClr val="E2E8F0"/>
+            </a:solidFill>
+            <a:prstDash val="solid"/>
+          </a:ln>
+          <a:effectLst>
+            <a:outerShdw blurRad="76200" dist="38100" dir="5400000" algn="bl" rotWithShape="0">
+              <a:srgbClr val="000000">
+                <a:alpha val="10000"/>
+              </a:srgbClr>
+            </a:outerShdw>
+          </a:effectLst>
+        </p:spPr>
+        <p:txBody>
+          <a:bodyPr/>
+          <a:lstStyle/>
+          <a:p>
+            <a:endParaRPr lang="en-US"/>
+          </a:p>
+        </p:txBody>
+      </p:sp>
+      <p:sp>
+        <p:nvSpPr>
+          <p:cNvPr id="12" name="Shape 10"/>
+          <p:cNvSpPr/>
+          <p:nvPr/>
+        </p:nvSpPr>
+        <p:spPr>
+          <a:xfrm>
+            <a:off x="502920" y="2048256"/>
+            <a:ext cx="64008" cy="548640"/>
+          </a:xfrm>
+          <a:prstGeom prst="roundRect">
+            <a:avLst>
+              <a:gd name="adj" fmla="val 42857"/>
+            </a:avLst>
+          </a:prstGeom>
+          <a:solidFill>
+            <a:srgbClr val="FF6348"/>
+          </a:solidFill>
+          <a:ln/>
+        </p:spPr>
+        <p:txBody>
+          <a:bodyPr/>
+          <a:lstStyle/>
+          <a:p>
+            <a:endParaRPr lang="en-US"/>
+          </a:p>
+        </p:txBody>
+      </p:sp>
+      <p:sp>
+        <p:nvSpPr>
+          <p:cNvPr id="13" name="Shape 11"/>
+          <p:cNvSpPr/>
+          <p:nvPr/>
+        </p:nvSpPr>
+        <p:spPr>
+          <a:xfrm>
+            <a:off x="731520" y="2130552"/>
+            <a:ext cx="384048" cy="384048"/>
+          </a:xfrm>
+          <a:prstGeom prst="roundRect">
+            <a:avLst>
+              <a:gd name="adj" fmla="val 16667"/>
+            </a:avLst>
+          </a:prstGeom>
+          <a:solidFill>
+            <a:srgbClr val="FF6348"/>
+          </a:solidFill>
+          <a:ln/>
+        </p:spPr>
+        <p:txBody>
+          <a:bodyPr/>
+          <a:lstStyle/>
+          <a:p>
+            <a:endParaRPr lang="en-US"/>
+          </a:p>
+        </p:txBody>
+      </p:sp>
+      <p:sp>
+        <p:nvSpPr>
+          <p:cNvPr id="14" name="Text 12"/>
+          <p:cNvSpPr/>
+          <p:nvPr/>
+        </p:nvSpPr>
+        <p:spPr>
+          <a:xfrm>
+            <a:off x="731520" y="2130552"/>
+            <a:ext cx="384048" cy="384048"/>
+          </a:xfrm>
+          <a:prstGeom prst="rect">
+            <a:avLst/>
+          </a:prstGeom>
+          <a:noFill/>
+          <a:ln/>
+        </p:spPr>
+        <p:txBody>
+          <a:bodyPr wrap="square" rtlCol="0" anchor="ctr"/>
+          <a:lstStyle/>
+          <a:p>
+            <a:pPr marL="0" indent="0" algn="ctr">
+              <a:buNone/>
+            </a:pPr>
+            <a:r>
+              <a:rPr lang="en-US" sz="1800" b="1" dirty="0">
+                <a:solidFill>
+                  <a:srgbClr val="FFFFFF"/>
+                </a:solidFill>
+                <a:latin typeface="Calibri" pitchFamily="34" charset="0"/>
+                <a:ea typeface="Calibri" pitchFamily="34" charset="-122"/>
+                <a:cs typeface="Calibri" pitchFamily="34" charset="-120"/>
+              </a:rPr>
+              <a:t>⚙</a:t>
+            </a:r>
+            <a:endParaRPr lang="en-US" sz="1800" dirty="0"/>
+          </a:p>
+        </p:txBody>
+      </p:sp>
+      <p:sp>
+        <p:nvSpPr>
+          <p:cNvPr id="15" name="Text 13"/>
+          <p:cNvSpPr/>
+          <p:nvPr/>
+        </p:nvSpPr>
+        <p:spPr>
+          <a:xfrm>
+            <a:off x="1234440" y="2066544"/>
+            <a:ext cx="2880360" cy="512064"/>
+          </a:xfrm>
+          <a:prstGeom prst="rect">
+            <a:avLst/>
+          </a:prstGeom>
+          <a:noFill/>
+          <a:ln/>
+        </p:spPr>
+        <p:txBody>
+          <a:bodyPr wrap="square" rtlCol="0" anchor="ctr"/>
+          <a:lstStyle/>
+          <a:p>
+            <a:pPr marL="0" indent="0">
+              <a:buNone/>
+            </a:pPr>
+            <a:r>
+              <a:rPr lang="en-US" sz="1300" b="1" dirty="0">
+                <a:solidFill>
+                  <a:srgbClr val="1E293B"/>
+                </a:solidFill>
+                <a:latin typeface="Calibri" pitchFamily="34" charset="0"/>
+                <a:ea typeface="Calibri" pitchFamily="34" charset="-122"/>
+                <a:cs typeface="Calibri" pitchFamily="34" charset="-120"/>
+              </a:rPr>
+              <a:t>Entity</a:t>
+            </a:r>
+            <a:endParaRPr lang="en-US" sz="1300" dirty="0"/>
+          </a:p>
+        </p:txBody>
+      </p:sp>
+      <p:sp>
+        <p:nvSpPr>
+          <p:cNvPr id="16" name="Text 14"/>
+          <p:cNvSpPr/>
+          <p:nvPr/>
+        </p:nvSpPr>
+        <p:spPr>
+          <a:xfrm>
+            <a:off x="4206240" y="2066544"/>
+            <a:ext cx="4251960" cy="512064"/>
+          </a:xfrm>
+          <a:prstGeom prst="rect">
+            <a:avLst/>
+          </a:prstGeom>
+          <a:noFill/>
+          <a:ln/>
+        </p:spPr>
+        <p:txBody>
+          <a:bodyPr wrap="square" rtlCol="0" anchor="ctr"/>
+          <a:lstStyle/>
+          <a:p>
+            <a:pPr marL="0" indent="0">
+              <a:lnSpc>
+                <a:spcPct val="100000"/>
+              </a:lnSpc>
+              <a:buNone/>
+            </a:pPr>
+            <a:r>
+              <a:rPr lang="en-US" sz="1100" dirty="0">
+                <a:solidFill>
+                  <a:srgbClr val="64748B"/>
+                </a:solidFill>
+                <a:latin typeface="Calibri" pitchFamily="34" charset="0"/>
+                <a:ea typeface="Calibri" pitchFamily="34" charset="-122"/>
+                <a:cs typeface="Calibri" pitchFamily="34" charset="-120"/>
+              </a:rPr>
+              <a:t>A named thing pulled from the text — a feature, person, product or concept. These are the nodes of the graph.</a:t>
+            </a:r>
+            <a:endParaRPr lang="en-US" sz="1100" dirty="0"/>
+          </a:p>
+        </p:txBody>
+      </p:sp>
+      <p:sp>
+        <p:nvSpPr>
+          <p:cNvPr id="17" name="Shape 15"/>
+          <p:cNvSpPr/>
+          <p:nvPr/>
+        </p:nvSpPr>
+        <p:spPr>
+          <a:xfrm>
+            <a:off x="502920" y="2724912"/>
+            <a:ext cx="8138160" cy="548640"/>
+          </a:xfrm>
+          <a:prstGeom prst="roundRect">
+            <a:avLst>
+              <a:gd name="adj" fmla="val 11667"/>
+            </a:avLst>
+          </a:prstGeom>
+          <a:solidFill>
+            <a:srgbClr val="FFFFFF"/>
+          </a:solidFill>
+          <a:ln w="9525">
+            <a:solidFill>
+              <a:srgbClr val="E2E8F0"/>
+            </a:solidFill>
+            <a:prstDash val="solid"/>
+          </a:ln>
+          <a:effectLst>
+            <a:outerShdw blurRad="76200" dist="38100" dir="5400000" algn="bl" rotWithShape="0">
+              <a:srgbClr val="000000">
+                <a:alpha val="10000"/>
+              </a:srgbClr>
+            </a:outerShdw>
+          </a:effectLst>
+        </p:spPr>
+        <p:txBody>
+          <a:bodyPr/>
+          <a:lstStyle/>
+          <a:p>
+            <a:endParaRPr lang="en-US"/>
+          </a:p>
+        </p:txBody>
+      </p:sp>
+      <p:sp>
+        <p:nvSpPr>
+          <p:cNvPr id="18" name="Shape 16"/>
+          <p:cNvSpPr/>
+          <p:nvPr/>
+        </p:nvSpPr>
+        <p:spPr>
+          <a:xfrm>
+            <a:off x="502920" y="2724912"/>
+            <a:ext cx="64008" cy="548640"/>
+          </a:xfrm>
+          <a:prstGeom prst="roundRect">
+            <a:avLst>
+              <a:gd name="adj" fmla="val 42857"/>
+            </a:avLst>
+          </a:prstGeom>
+          <a:solidFill>
+            <a:srgbClr val="7C3AED"/>
+          </a:solidFill>
+          <a:ln/>
+        </p:spPr>
+        <p:txBody>
+          <a:bodyPr/>
+          <a:lstStyle/>
+          <a:p>
+            <a:endParaRPr lang="en-US"/>
+          </a:p>
+        </p:txBody>
+      </p:sp>
+      <p:sp>
+        <p:nvSpPr>
+          <p:cNvPr id="19" name="Shape 17"/>
+          <p:cNvSpPr/>
+          <p:nvPr/>
+        </p:nvSpPr>
+        <p:spPr>
+          <a:xfrm>
+            <a:off x="731520" y="2807208"/>
+            <a:ext cx="384048" cy="384048"/>
+          </a:xfrm>
+          <a:prstGeom prst="roundRect">
+            <a:avLst>
+              <a:gd name="adj" fmla="val 16667"/>
+            </a:avLst>
+          </a:prstGeom>
+          <a:solidFill>
+            <a:srgbClr val="7C3AED"/>
+          </a:solidFill>
+          <a:ln/>
+        </p:spPr>
+        <p:txBody>
+          <a:bodyPr/>
+          <a:lstStyle/>
+          <a:p>
+            <a:endParaRPr lang="en-US"/>
+          </a:p>
+        </p:txBody>
+      </p:sp>
+      <p:sp>
+        <p:nvSpPr>
+          <p:cNvPr id="20" name="Text 18"/>
+          <p:cNvSpPr/>
+          <p:nvPr/>
+        </p:nvSpPr>
+        <p:spPr>
+          <a:xfrm>
+            <a:off x="731520" y="2807208"/>
+            <a:ext cx="384048" cy="384048"/>
+          </a:xfrm>
+          <a:prstGeom prst="rect">
+            <a:avLst/>
+          </a:prstGeom>
+          <a:noFill/>
+          <a:ln/>
+        </p:spPr>
+        <p:txBody>
+          <a:bodyPr wrap="square" rtlCol="0" anchor="ctr"/>
+          <a:lstStyle/>
+          <a:p>
+            <a:pPr marL="0" indent="0" algn="ctr">
+              <a:buNone/>
+            </a:pPr>
+            <a:r>
+              <a:rPr lang="en-US" sz="1800" b="1" dirty="0">
+                <a:solidFill>
+                  <a:srgbClr val="FFFFFF"/>
+                </a:solidFill>
+                <a:latin typeface="Calibri" pitchFamily="34" charset="0"/>
+                <a:ea typeface="Calibri" pitchFamily="34" charset="-122"/>
+                <a:cs typeface="Calibri" pitchFamily="34" charset="-120"/>
+              </a:rPr>
+              <a:t>★</a:t>
+            </a:r>
+            <a:endParaRPr lang="en-US" sz="1800" dirty="0"/>
+          </a:p>
+        </p:txBody>
+      </p:sp>
+      <p:sp>
+        <p:nvSpPr>
+          <p:cNvPr id="21" name="Text 19"/>
+          <p:cNvSpPr/>
+          <p:nvPr/>
+        </p:nvSpPr>
+        <p:spPr>
+          <a:xfrm>
+            <a:off x="1234440" y="2743200"/>
+            <a:ext cx="2880360" cy="512064"/>
+          </a:xfrm>
+          <a:prstGeom prst="rect">
+            <a:avLst/>
+          </a:prstGeom>
+          <a:noFill/>
+          <a:ln/>
+        </p:spPr>
+        <p:txBody>
+          <a:bodyPr wrap="square" rtlCol="0" anchor="ctr"/>
+          <a:lstStyle/>
+          <a:p>
+            <a:pPr marL="0" indent="0">
+              <a:buNone/>
+            </a:pPr>
+            <a:r>
+              <a:rPr lang="en-US" sz="1300" b="1" dirty="0">
+                <a:solidFill>
+                  <a:srgbClr val="1E293B"/>
+                </a:solidFill>
+                <a:latin typeface="Calibri" pitchFamily="34" charset="0"/>
+                <a:ea typeface="Calibri" pitchFamily="34" charset="-122"/>
+                <a:cs typeface="Calibri" pitchFamily="34" charset="-120"/>
+              </a:rPr>
+              <a:t>Relationship (edge)</a:t>
+            </a:r>
+            <a:endParaRPr lang="en-US" sz="1300" dirty="0"/>
+          </a:p>
+        </p:txBody>
+      </p:sp>
+      <p:sp>
+        <p:nvSpPr>
+          <p:cNvPr id="22" name="Text 20"/>
+          <p:cNvSpPr/>
+          <p:nvPr/>
+        </p:nvSpPr>
+        <p:spPr>
+          <a:xfrm>
+            <a:off x="4206240" y="2743200"/>
+            <a:ext cx="4251960" cy="512064"/>
+          </a:xfrm>
+          <a:prstGeom prst="rect">
+            <a:avLst/>
+          </a:prstGeom>
+          <a:noFill/>
+          <a:ln/>
+        </p:spPr>
+        <p:txBody>
+          <a:bodyPr wrap="square" rtlCol="0" anchor="ctr"/>
+          <a:lstStyle/>
+          <a:p>
+            <a:pPr marL="0" indent="0">
+              <a:lnSpc>
+                <a:spcPct val="100000"/>
+              </a:lnSpc>
+              <a:buNone/>
+            </a:pPr>
+            <a:r>
+              <a:rPr lang="en-US" sz="1100" dirty="0">
+                <a:solidFill>
+                  <a:srgbClr val="64748B"/>
+                </a:solidFill>
+                <a:latin typeface="Calibri" pitchFamily="34" charset="0"/>
+                <a:ea typeface="Calibri" pitchFamily="34" charset="-122"/>
+                <a:cs typeface="Calibri" pitchFamily="34" charset="-120"/>
+              </a:rPr>
+              <a:t>A connection between two entities — “X depends on Y,” “A is an alternative to B.” The lines of the graph.</a:t>
+            </a:r>
+            <a:endParaRPr lang="en-US" sz="1100" dirty="0"/>
+          </a:p>
+        </p:txBody>
+      </p:sp>
+      <p:sp>
+        <p:nvSpPr>
+          <p:cNvPr id="23" name="Shape 21"/>
+          <p:cNvSpPr/>
+          <p:nvPr/>
+        </p:nvSpPr>
+        <p:spPr>
+          <a:xfrm>
+            <a:off x="502920" y="3401568"/>
+            <a:ext cx="8138160" cy="548640"/>
+          </a:xfrm>
+          <a:prstGeom prst="roundRect">
+            <a:avLst>
+              <a:gd name="adj" fmla="val 11667"/>
+            </a:avLst>
+          </a:prstGeom>
+          <a:solidFill>
+            <a:srgbClr val="FFFFFF"/>
+          </a:solidFill>
+          <a:ln w="9525">
+            <a:solidFill>
+              <a:srgbClr val="E2E8F0"/>
+            </a:solidFill>
+            <a:prstDash val="solid"/>
+          </a:ln>
+          <a:effectLst>
+            <a:outerShdw blurRad="76200" dist="38100" dir="5400000" algn="bl" rotWithShape="0">
+              <a:srgbClr val="000000">
+                <a:alpha val="10000"/>
+              </a:srgbClr>
+            </a:outerShdw>
+          </a:effectLst>
+        </p:spPr>
+        <p:txBody>
+          <a:bodyPr/>
+          <a:lstStyle/>
+          <a:p>
+            <a:endParaRPr lang="en-US"/>
+          </a:p>
+        </p:txBody>
+      </p:sp>
+      <p:sp>
+        <p:nvSpPr>
+          <p:cNvPr id="24" name="Shape 22"/>
+          <p:cNvSpPr/>
+          <p:nvPr/>
+        </p:nvSpPr>
+        <p:spPr>
+          <a:xfrm>
+            <a:off x="502920" y="3401568"/>
+            <a:ext cx="64008" cy="548640"/>
+          </a:xfrm>
+          <a:prstGeom prst="roundRect">
+            <a:avLst>
+              <a:gd name="adj" fmla="val 42857"/>
+            </a:avLst>
+          </a:prstGeom>
+          <a:solidFill>
+            <a:srgbClr val="2563EB"/>
+          </a:solidFill>
+          <a:ln/>
+        </p:spPr>
+        <p:txBody>
+          <a:bodyPr/>
+          <a:lstStyle/>
+          <a:p>
+            <a:endParaRPr lang="en-US"/>
+          </a:p>
+        </p:txBody>
+      </p:sp>
+      <p:sp>
+        <p:nvSpPr>
+          <p:cNvPr id="25" name="Shape 23"/>
+          <p:cNvSpPr/>
+          <p:nvPr/>
+        </p:nvSpPr>
+        <p:spPr>
+          <a:xfrm>
+            <a:off x="731520" y="3483864"/>
+            <a:ext cx="384048" cy="384048"/>
+          </a:xfrm>
+          <a:prstGeom prst="roundRect">
+            <a:avLst>
+              <a:gd name="adj" fmla="val 16667"/>
+            </a:avLst>
+          </a:prstGeom>
+          <a:solidFill>
+            <a:srgbClr val="2563EB"/>
+          </a:solidFill>
+          <a:ln/>
+        </p:spPr>
+        <p:txBody>
+          <a:bodyPr/>
+          <a:lstStyle/>
+          <a:p>
+            <a:endParaRPr lang="en-US"/>
+          </a:p>
+        </p:txBody>
+      </p:sp>
+      <p:sp>
+        <p:nvSpPr>
+          <p:cNvPr id="26" name="Text 24"/>
+          <p:cNvSpPr/>
+          <p:nvPr/>
+        </p:nvSpPr>
+        <p:spPr>
+          <a:xfrm>
+            <a:off x="731520" y="3483864"/>
+            <a:ext cx="384048" cy="384048"/>
+          </a:xfrm>
+          <a:prstGeom prst="rect">
+            <a:avLst/>
+          </a:prstGeom>
+          <a:noFill/>
+          <a:ln/>
+        </p:spPr>
+        <p:txBody>
+          <a:bodyPr wrap="square" rtlCol="0" anchor="ctr"/>
+          <a:lstStyle/>
+          <a:p>
+            <a:pPr marL="0" indent="0" algn="ctr">
+              <a:buNone/>
+            </a:pPr>
+            <a:r>
+              <a:rPr lang="en-US" sz="1800" b="1" dirty="0">
+                <a:solidFill>
+                  <a:srgbClr val="FFFFFF"/>
+                </a:solidFill>
+                <a:latin typeface="Calibri" pitchFamily="34" charset="0"/>
+                <a:ea typeface="Calibri" pitchFamily="34" charset="-122"/>
+                <a:cs typeface="Calibri" pitchFamily="34" charset="-120"/>
+              </a:rPr>
+              <a:t>◆</a:t>
+            </a:r>
+            <a:endParaRPr lang="en-US" sz="1800" dirty="0"/>
+          </a:p>
+        </p:txBody>
+      </p:sp>
+      <p:sp>
+        <p:nvSpPr>
+          <p:cNvPr id="27" name="Text 25"/>
+          <p:cNvSpPr/>
+          <p:nvPr/>
+        </p:nvSpPr>
+        <p:spPr>
+          <a:xfrm>
+            <a:off x="1234440" y="3419856"/>
+            <a:ext cx="2880360" cy="512064"/>
+          </a:xfrm>
+          <a:prstGeom prst="rect">
+            <a:avLst/>
+          </a:prstGeom>
+          <a:noFill/>
+          <a:ln/>
+        </p:spPr>
+        <p:txBody>
+          <a:bodyPr wrap="square" rtlCol="0" anchor="ctr"/>
+          <a:lstStyle/>
+          <a:p>
+            <a:pPr marL="0" indent="0">
+              <a:buNone/>
+            </a:pPr>
+            <a:r>
+              <a:rPr lang="en-US" sz="1300" b="1" dirty="0">
+                <a:solidFill>
+                  <a:srgbClr val="1E293B"/>
+                </a:solidFill>
+                <a:latin typeface="Calibri" pitchFamily="34" charset="0"/>
+                <a:ea typeface="Calibri" pitchFamily="34" charset="-122"/>
+                <a:cs typeface="Calibri" pitchFamily="34" charset="-120"/>
+              </a:rPr>
+              <a:t>LLM</a:t>
+            </a:r>
+            <a:endParaRPr lang="en-US" sz="1300" dirty="0"/>
+          </a:p>
+        </p:txBody>
+      </p:sp>
+      <p:sp>
+        <p:nvSpPr>
+          <p:cNvPr id="28" name="Text 26"/>
+          <p:cNvSpPr/>
+          <p:nvPr/>
+        </p:nvSpPr>
+        <p:spPr>
+          <a:xfrm>
+            <a:off x="4206240" y="3419856"/>
+            <a:ext cx="4251960" cy="512064"/>
+          </a:xfrm>
+          <a:prstGeom prst="rect">
+            <a:avLst/>
+          </a:prstGeom>
+          <a:noFill/>
+          <a:ln/>
+        </p:spPr>
+        <p:txBody>
+          <a:bodyPr wrap="square" rtlCol="0" anchor="ctr"/>
+          <a:lstStyle/>
+          <a:p>
+            <a:pPr marL="0" indent="0">
+              <a:lnSpc>
+                <a:spcPct val="100000"/>
+              </a:lnSpc>
+              <a:buNone/>
+            </a:pPr>
+            <a:r>
+              <a:rPr lang="en-US" sz="1100" dirty="0">
+                <a:solidFill>
+                  <a:srgbClr val="64748B"/>
+                </a:solidFill>
+                <a:latin typeface="Calibri" pitchFamily="34" charset="0"/>
+                <a:ea typeface="Calibri" pitchFamily="34" charset="-122"/>
+                <a:cs typeface="Calibri" pitchFamily="34" charset="-120"/>
+              </a:rPr>
+              <a:t>Large Language Model — reads and writes language; here it extracts entities and reasons over what’s retrieved.</a:t>
+            </a:r>
+            <a:endParaRPr lang="en-US" sz="1100" dirty="0"/>
+          </a:p>
+        </p:txBody>
+      </p:sp>
+      <p:sp>
+        <p:nvSpPr>
+          <p:cNvPr id="29" name="Shape 27"/>
+          <p:cNvSpPr/>
+          <p:nvPr/>
+        </p:nvSpPr>
+        <p:spPr>
+          <a:xfrm>
+            <a:off x="502920" y="4078224"/>
+            <a:ext cx="8138160" cy="548640"/>
+          </a:xfrm>
+          <a:prstGeom prst="roundRect">
+            <a:avLst>
+              <a:gd name="adj" fmla="val 11667"/>
+            </a:avLst>
+          </a:prstGeom>
+          <a:solidFill>
+            <a:srgbClr val="FFFFFF"/>
+          </a:solidFill>
+          <a:ln w="9525">
+            <a:solidFill>
+              <a:srgbClr val="E2E8F0"/>
+            </a:solidFill>
+            <a:prstDash val="solid"/>
+          </a:ln>
+          <a:effectLst>
+            <a:outerShdw blurRad="76200" dist="38100" dir="5400000" algn="bl" rotWithShape="0">
+              <a:srgbClr val="000000">
+                <a:alpha val="10000"/>
+              </a:srgbClr>
+            </a:outerShdw>
+          </a:effectLst>
+        </p:spPr>
+        <p:txBody>
+          <a:bodyPr/>
+          <a:lstStyle/>
+          <a:p>
+            <a:endParaRPr lang="en-US"/>
+          </a:p>
+        </p:txBody>
+      </p:sp>
+      <p:sp>
+        <p:nvSpPr>
+          <p:cNvPr id="30" name="Shape 28"/>
+          <p:cNvSpPr/>
+          <p:nvPr/>
+        </p:nvSpPr>
+        <p:spPr>
+          <a:xfrm>
+            <a:off x="502920" y="4078224"/>
+            <a:ext cx="64008" cy="548640"/>
+          </a:xfrm>
+          <a:prstGeom prst="roundRect">
+            <a:avLst>
+              <a:gd name="adj" fmla="val 42857"/>
+            </a:avLst>
+          </a:prstGeom>
+          <a:solidFill>
+            <a:srgbClr val="0D9488"/>
+          </a:solidFill>
+          <a:ln/>
+        </p:spPr>
+        <p:txBody>
+          <a:bodyPr/>
+          <a:lstStyle/>
+          <a:p>
+            <a:endParaRPr lang="en-US"/>
+          </a:p>
+        </p:txBody>
+      </p:sp>
+      <p:sp>
+        <p:nvSpPr>
+          <p:cNvPr id="31" name="Shape 29"/>
+          <p:cNvSpPr/>
+          <p:nvPr/>
+        </p:nvSpPr>
+        <p:spPr>
+          <a:xfrm>
+            <a:off x="731520" y="4160520"/>
+            <a:ext cx="384048" cy="384048"/>
+          </a:xfrm>
+          <a:prstGeom prst="roundRect">
+            <a:avLst>
+              <a:gd name="adj" fmla="val 16667"/>
+            </a:avLst>
+          </a:prstGeom>
+          <a:solidFill>
+            <a:srgbClr val="0D9488"/>
+          </a:solidFill>
+          <a:ln/>
+        </p:spPr>
+        <p:txBody>
+          <a:bodyPr/>
+          <a:lstStyle/>
+          <a:p>
+            <a:endParaRPr lang="en-US"/>
+          </a:p>
+        </p:txBody>
+      </p:sp>
+      <p:sp>
+        <p:nvSpPr>
+          <p:cNvPr id="32" name="Text 30"/>
+          <p:cNvSpPr/>
+          <p:nvPr/>
+        </p:nvSpPr>
+        <p:spPr>
+          <a:xfrm>
+            <a:off x="731520" y="4160520"/>
+            <a:ext cx="384048" cy="384048"/>
+          </a:xfrm>
+          <a:prstGeom prst="rect">
+            <a:avLst/>
+          </a:prstGeom>
+          <a:noFill/>
+          <a:ln/>
+        </p:spPr>
+        <p:txBody>
+          <a:bodyPr wrap="square" rtlCol="0" anchor="ctr"/>
+          <a:lstStyle/>
+          <a:p>
+            <a:pPr marL="0" indent="0" algn="ctr">
+              <a:buNone/>
+            </a:pPr>
+            <a:r>
+              <a:rPr lang="en-US" sz="1800" b="1" dirty="0">
+                <a:solidFill>
+                  <a:srgbClr val="FFFFFF"/>
+                </a:solidFill>
+                <a:latin typeface="Calibri" pitchFamily="34" charset="0"/>
+                <a:ea typeface="Calibri" pitchFamily="34" charset="-122"/>
+                <a:cs typeface="Calibri" pitchFamily="34" charset="-120"/>
+              </a:rPr>
+              <a:t>?</a:t>
+            </a:r>
+            <a:endParaRPr lang="en-US" sz="1800" dirty="0"/>
+          </a:p>
+        </p:txBody>
+      </p:sp>
+      <p:sp>
+        <p:nvSpPr>
+          <p:cNvPr id="33" name="Text 31"/>
+          <p:cNvSpPr/>
+          <p:nvPr/>
+        </p:nvSpPr>
+        <p:spPr>
+          <a:xfrm>
+            <a:off x="1234440" y="4096512"/>
+            <a:ext cx="2880360" cy="512064"/>
+          </a:xfrm>
+          <a:prstGeom prst="rect">
+            <a:avLst/>
+          </a:prstGeom>
+          <a:noFill/>
+          <a:ln/>
+        </p:spPr>
+        <p:txBody>
+          <a:bodyPr wrap="square" rtlCol="0" anchor="ctr"/>
+          <a:lstStyle/>
+          <a:p>
+            <a:pPr marL="0" indent="0">
+              <a:buNone/>
+            </a:pPr>
+            <a:r>
+              <a:rPr lang="en-US" sz="1300" b="1" dirty="0">
+                <a:solidFill>
+                  <a:srgbClr val="1E293B"/>
+                </a:solidFill>
+                <a:latin typeface="Calibri" pitchFamily="34" charset="0"/>
+                <a:ea typeface="Calibri" pitchFamily="34" charset="-122"/>
+                <a:cs typeface="Calibri" pitchFamily="34" charset="-120"/>
+              </a:rPr>
+              <a:t>MCP</a:t>
+            </a:r>
+            <a:endParaRPr lang="en-US" sz="1300" dirty="0"/>
+          </a:p>
+        </p:txBody>
+      </p:sp>
+      <p:sp>
+        <p:nvSpPr>
+          <p:cNvPr id="34" name="Text 32"/>
+          <p:cNvSpPr/>
+          <p:nvPr/>
+        </p:nvSpPr>
+        <p:spPr>
+          <a:xfrm>
+            <a:off x="4206240" y="4096512"/>
+            <a:ext cx="4251960" cy="512064"/>
+          </a:xfrm>
+          <a:prstGeom prst="rect">
+            <a:avLst/>
+          </a:prstGeom>
+          <a:noFill/>
+          <a:ln/>
+        </p:spPr>
+        <p:txBody>
+          <a:bodyPr wrap="square" rtlCol="0" anchor="ctr"/>
+          <a:lstStyle/>
+          <a:p>
+            <a:pPr marL="0" indent="0">
+              <a:lnSpc>
+                <a:spcPct val="100000"/>
+              </a:lnSpc>
+              <a:buNone/>
+            </a:pPr>
+            <a:r>
+              <a:rPr lang="en-US" sz="1100" dirty="0">
+                <a:solidFill>
+                  <a:srgbClr val="64748B"/>
+                </a:solidFill>
+                <a:latin typeface="Calibri" pitchFamily="34" charset="0"/>
+                <a:ea typeface="Calibri" pitchFamily="34" charset="-122"/>
+                <a:cs typeface="Calibri" pitchFamily="34" charset="-120"/>
+              </a:rPr>
+              <a:t>Model Context Protocol — an open standard for a model to call external tools uniformly; the hub exposes retrieval as one.</a:t>
+            </a:r>
+            <a:endParaRPr lang="en-US" sz="1100" dirty="0"/>
+          </a:p>
+        </p:txBody>
+      </p:sp>
+      <p:sp>
+        <p:nvSpPr>
+          <p:cNvPr id="35" name="Text 33"/>
+          <p:cNvSpPr/>
+          <p:nvPr/>
+        </p:nvSpPr>
+        <p:spPr>
+          <a:xfrm>
+            <a:off x="7982520" y="4828032"/>
+            <a:ext cx="750000" cy="256032"/>
+          </a:xfrm>
+          <a:prstGeom prst="rect">
+            <a:avLst/>
+          </a:prstGeom>
+          <a:noFill/>
+          <a:ln/>
+        </p:spPr>
+        <p:txBody>
+          <a:bodyPr wrap="square" rtlCol="0" anchor="ctr"/>
+          <a:lstStyle/>
+          <a:p>
+            <a:pPr marL="0" indent="0" algn="r">
+              <a:buNone/>
+            </a:pPr>
+            <a:r>
+              <a:rPr lang="en-US" sz="900" dirty="0">
+                <a:solidFill>
+                  <a:srgbClr val="94A3B8"/>
+                </a:solidFill>
+                <a:latin typeface="Calibri" pitchFamily="34" charset="0"/>
+                <a:ea typeface="Calibri" pitchFamily="34" charset="-122"/>
+                <a:cs typeface="Calibri" pitchFamily="34" charset="-120"/>
+              </a:rPr>
+              <a:t>Glossary</a:t>
+            </a:r>
+            <a:endParaRPr lang="en-US" sz="900" dirty="0"/>
+          </a:p>
+        </p:txBody>
+      </p:sp>
+    </p:spTree>
+  </p:cSld>
+  <p:clrMapOvr>
+    <a:masterClrMapping/>
+  </p:clrMapOvr>
+</p:sld>
+</file>
+
+<file path=ppt/slides/slide27.xml><?xml version="1.0" encoding="utf-8"?>
 <p:sld xmlns:a="http://schemas.openxmlformats.org/drawingml/2006/main" xmlns:r="http://schemas.openxmlformats.org/officeDocument/2006/relationships" xmlns:p="http://schemas.openxmlformats.org/presentationml/2006/main">
   <p:cSld name="Slide 17">
     <p:bg>

</xml_diff>